<commit_message>
docs: improve defense deck readability
</commit_message>
<xml_diff>
--- a/AI Project Passport - Energy Company/Защита паспорта проекта — НЭК ТЕХ.pptx
+++ b/AI Project Passport - Energy Company/Защита паспорта проекта — НЭК ТЕХ.pptx
@@ -3419,12 +3419,12 @@
         </p:nvSpPr>
         <p:spPr>
           <a:xfrm>
-            <a:off x="685800" y="2148840"/>
-            <a:ext cx="2084832" cy="1261872"/>
+            <a:off x="566928" y="2084832"/>
+            <a:ext cx="2377440" cy="1417320"/>
           </a:xfrm>
           <a:prstGeom prst="roundRect">
             <a:avLst>
-              <a:gd name="adj" fmla="val 5797"/>
+              <a:gd name="adj" fmla="val 5161"/>
             </a:avLst>
           </a:prstGeom>
           <a:solidFill>
@@ -3446,8 +3446,8 @@
         </p:nvSpPr>
         <p:spPr>
           <a:xfrm>
-            <a:off x="850392" y="2350008"/>
-            <a:ext cx="475488" cy="475488"/>
+            <a:off x="749808" y="2295144"/>
+            <a:ext cx="493776" cy="493776"/>
           </a:xfrm>
           <a:prstGeom prst="ellipse">
             <a:avLst/>
@@ -3471,8 +3471,8 @@
         </p:nvSpPr>
         <p:spPr>
           <a:xfrm>
-            <a:off x="850392" y="2478024"/>
-            <a:ext cx="475488" cy="146304"/>
+            <a:off x="749808" y="2432304"/>
+            <a:ext cx="493776" cy="146304"/>
           </a:xfrm>
           <a:prstGeom prst="rect">
             <a:avLst/>
@@ -3488,14 +3488,14 @@
               <a:buNone/>
             </a:pPr>
             <a:r>
-              <a:rPr lang="en-US" sz="1000" b="1" dirty="0">
+              <a:rPr lang="en-US" sz="1050" b="1" dirty="0">
                 <a:solidFill>
                   <a:srgbClr val="FFFFFF"/>
                 </a:solidFill>
               </a:rPr>
               <a:t>1</a:t>
             </a:r>
-            <a:endParaRPr lang="en-US" sz="1000" dirty="0"/>
+            <a:endParaRPr lang="en-US" sz="1050" dirty="0"/>
           </a:p>
         </p:txBody>
       </p:sp>
@@ -3507,44 +3507,8 @@
         </p:nvSpPr>
         <p:spPr>
           <a:xfrm>
-            <a:off x="1453896" y="2350008"/>
-            <a:ext cx="1097280" cy="228600"/>
-          </a:xfrm>
-          <a:prstGeom prst="rect">
-            <a:avLst/>
-          </a:prstGeom>
-          <a:noFill/>
-          <a:ln/>
-        </p:spPr>
-        <p:txBody>
-          <a:bodyPr wrap="square" lIns="0" tIns="0" rIns="0" bIns="0" rtlCol="0" anchor="ctr"/>
-          <a:lstStyle/>
-          <a:p>
-            <a:pPr indent="0" marL="0">
-              <a:buNone/>
-            </a:pPr>
-            <a:r>
-              <a:rPr lang="en-US" sz="1400" b="1" dirty="0">
-                <a:solidFill>
-                  <a:srgbClr val="18302C"/>
-                </a:solidFill>
-              </a:rPr>
-              <a:t>ИБ</a:t>
-            </a:r>
-            <a:endParaRPr lang="en-US" sz="1400" dirty="0"/>
-          </a:p>
-        </p:txBody>
-      </p:sp>
-      <p:sp>
-        <p:nvSpPr>
-          <p:cNvPr id="10" name="Text 8"/>
-          <p:cNvSpPr/>
-          <p:nvPr/>
-        </p:nvSpPr>
-        <p:spPr>
-          <a:xfrm>
-            <a:off x="850392" y="2953512"/>
-            <a:ext cx="1700784" cy="201168"/>
+            <a:off x="1371600" y="2304288"/>
+            <a:ext cx="1389888" cy="256032"/>
           </a:xfrm>
           <a:prstGeom prst="rect">
             <a:avLst/>
@@ -3562,14 +3526,52 @@
               <a:buNone/>
             </a:pPr>
             <a:r>
-              <a:rPr lang="en-US" sz="950" dirty="0">
+              <a:rPr lang="en-US" sz="1350" b="1" dirty="0">
+                <a:solidFill>
+                  <a:srgbClr val="18302C"/>
+                </a:solidFill>
+              </a:rPr>
+              <a:t>ИБ</a:t>
+            </a:r>
+            <a:endParaRPr lang="en-US" sz="1350" dirty="0"/>
+          </a:p>
+        </p:txBody>
+      </p:sp>
+      <p:sp>
+        <p:nvSpPr>
+          <p:cNvPr id="10" name="Text 8"/>
+          <p:cNvSpPr/>
+          <p:nvPr/>
+        </p:nvSpPr>
+        <p:spPr>
+          <a:xfrm>
+            <a:off x="749808" y="2999232"/>
+            <a:ext cx="1956816" cy="228600"/>
+          </a:xfrm>
+          <a:prstGeom prst="rect">
+            <a:avLst/>
+          </a:prstGeom>
+          <a:noFill/>
+          <a:ln/>
+        </p:spPr>
+        <p:txBody>
+          <a:bodyPr wrap="square" lIns="0" tIns="0" rIns="0" bIns="0" rtlCol="0" anchor="ctr">
+            <a:normAutofit/>
+          </a:bodyPr>
+          <a:lstStyle/>
+          <a:p>
+            <a:pPr indent="0" marL="0">
+              <a:buNone/>
+            </a:pPr>
+            <a:r>
+              <a:rPr lang="en-US" sz="1130" dirty="0">
                 <a:solidFill>
                   <a:srgbClr val="60746F"/>
                 </a:solidFill>
               </a:rPr>
               <a:t>рамки, данные, допуск</a:t>
             </a:r>
-            <a:endParaRPr lang="en-US" sz="950" dirty="0"/>
+            <a:endParaRPr lang="en-US" sz="1130" dirty="0"/>
           </a:p>
         </p:txBody>
       </p:sp>
@@ -3581,12 +3583,12 @@
         </p:nvSpPr>
         <p:spPr>
           <a:xfrm>
-            <a:off x="3154680" y="2148840"/>
-            <a:ext cx="2084832" cy="1261872"/>
+            <a:off x="3456432" y="2084832"/>
+            <a:ext cx="2377440" cy="1417320"/>
           </a:xfrm>
           <a:prstGeom prst="roundRect">
             <a:avLst>
-              <a:gd name="adj" fmla="val 5797"/>
+              <a:gd name="adj" fmla="val 5161"/>
             </a:avLst>
           </a:prstGeom>
           <a:solidFill>
@@ -3608,8 +3610,8 @@
         </p:nvSpPr>
         <p:spPr>
           <a:xfrm>
-            <a:off x="3319272" y="2350008"/>
-            <a:ext cx="475488" cy="475488"/>
+            <a:off x="3639312" y="2295144"/>
+            <a:ext cx="493776" cy="493776"/>
           </a:xfrm>
           <a:prstGeom prst="ellipse">
             <a:avLst/>
@@ -3633,8 +3635,8 @@
         </p:nvSpPr>
         <p:spPr>
           <a:xfrm>
-            <a:off x="3319272" y="2478024"/>
-            <a:ext cx="475488" cy="146304"/>
+            <a:off x="3639312" y="2432304"/>
+            <a:ext cx="493776" cy="146304"/>
           </a:xfrm>
           <a:prstGeom prst="rect">
             <a:avLst/>
@@ -3650,14 +3652,14 @@
               <a:buNone/>
             </a:pPr>
             <a:r>
-              <a:rPr lang="en-US" sz="1000" b="1" dirty="0">
+              <a:rPr lang="en-US" sz="1050" b="1" dirty="0">
                 <a:solidFill>
                   <a:srgbClr val="FFFFFF"/>
                 </a:solidFill>
               </a:rPr>
               <a:t>2</a:t>
             </a:r>
-            <a:endParaRPr lang="en-US" sz="1000" dirty="0"/>
+            <a:endParaRPr lang="en-US" sz="1050" dirty="0"/>
           </a:p>
         </p:txBody>
       </p:sp>
@@ -3669,44 +3671,8 @@
         </p:nvSpPr>
         <p:spPr>
           <a:xfrm>
-            <a:off x="3922776" y="2350008"/>
-            <a:ext cx="1097280" cy="228600"/>
-          </a:xfrm>
-          <a:prstGeom prst="rect">
-            <a:avLst/>
-          </a:prstGeom>
-          <a:noFill/>
-          <a:ln/>
-        </p:spPr>
-        <p:txBody>
-          <a:bodyPr wrap="square" lIns="0" tIns="0" rIns="0" bIns="0" rtlCol="0" anchor="ctr"/>
-          <a:lstStyle/>
-          <a:p>
-            <a:pPr indent="0" marL="0">
-              <a:buNone/>
-            </a:pPr>
-            <a:r>
-              <a:rPr lang="en-US" sz="1400" b="1" dirty="0">
-                <a:solidFill>
-                  <a:srgbClr val="18302C"/>
-                </a:solidFill>
-              </a:rPr>
-              <a:t>ИТ</a:t>
-            </a:r>
-            <a:endParaRPr lang="en-US" sz="1400" dirty="0"/>
-          </a:p>
-        </p:txBody>
-      </p:sp>
-      <p:sp>
-        <p:nvSpPr>
-          <p:cNvPr id="15" name="Text 13"/>
-          <p:cNvSpPr/>
-          <p:nvPr/>
-        </p:nvSpPr>
-        <p:spPr>
-          <a:xfrm>
-            <a:off x="3319272" y="2953512"/>
-            <a:ext cx="1700784" cy="201168"/>
+            <a:off x="4261104" y="2304288"/>
+            <a:ext cx="1389888" cy="256032"/>
           </a:xfrm>
           <a:prstGeom prst="rect">
             <a:avLst/>
@@ -3724,14 +3690,52 @@
               <a:buNone/>
             </a:pPr>
             <a:r>
-              <a:rPr lang="en-US" sz="950" dirty="0">
+              <a:rPr lang="en-US" sz="1350" b="1" dirty="0">
+                <a:solidFill>
+                  <a:srgbClr val="18302C"/>
+                </a:solidFill>
+              </a:rPr>
+              <a:t>ИТ</a:t>
+            </a:r>
+            <a:endParaRPr lang="en-US" sz="1350" dirty="0"/>
+          </a:p>
+        </p:txBody>
+      </p:sp>
+      <p:sp>
+        <p:nvSpPr>
+          <p:cNvPr id="15" name="Text 13"/>
+          <p:cNvSpPr/>
+          <p:nvPr/>
+        </p:nvSpPr>
+        <p:spPr>
+          <a:xfrm>
+            <a:off x="3639312" y="2999232"/>
+            <a:ext cx="1956816" cy="228600"/>
+          </a:xfrm>
+          <a:prstGeom prst="rect">
+            <a:avLst/>
+          </a:prstGeom>
+          <a:noFill/>
+          <a:ln/>
+        </p:spPr>
+        <p:txBody>
+          <a:bodyPr wrap="square" lIns="0" tIns="0" rIns="0" bIns="0" rtlCol="0" anchor="ctr">
+            <a:normAutofit/>
+          </a:bodyPr>
+          <a:lstStyle/>
+          <a:p>
+            <a:pPr indent="0" marL="0">
+              <a:buNone/>
+            </a:pPr>
+            <a:r>
+              <a:rPr lang="en-US" sz="1130" dirty="0">
                 <a:solidFill>
                   <a:srgbClr val="60746F"/>
                 </a:solidFill>
               </a:rPr>
               <a:t>инфраструктура, Service Desk</a:t>
             </a:r>
-            <a:endParaRPr lang="en-US" sz="950" dirty="0"/>
+            <a:endParaRPr lang="en-US" sz="1130" dirty="0"/>
           </a:p>
         </p:txBody>
       </p:sp>
@@ -3743,12 +3747,12 @@
         </p:nvSpPr>
         <p:spPr>
           <a:xfrm>
-            <a:off x="5623560" y="2148840"/>
-            <a:ext cx="2084832" cy="1261872"/>
+            <a:off x="6345936" y="2084832"/>
+            <a:ext cx="2377440" cy="1417320"/>
           </a:xfrm>
           <a:prstGeom prst="roundRect">
             <a:avLst>
-              <a:gd name="adj" fmla="val 5797"/>
+              <a:gd name="adj" fmla="val 5161"/>
             </a:avLst>
           </a:prstGeom>
           <a:solidFill>
@@ -3770,8 +3774,8 @@
         </p:nvSpPr>
         <p:spPr>
           <a:xfrm>
-            <a:off x="5788152" y="2350008"/>
-            <a:ext cx="475488" cy="475488"/>
+            <a:off x="6528816" y="2295144"/>
+            <a:ext cx="493776" cy="493776"/>
           </a:xfrm>
           <a:prstGeom prst="ellipse">
             <a:avLst/>
@@ -3795,8 +3799,8 @@
         </p:nvSpPr>
         <p:spPr>
           <a:xfrm>
-            <a:off x="5788152" y="2478024"/>
-            <a:ext cx="475488" cy="146304"/>
+            <a:off x="6528816" y="2432304"/>
+            <a:ext cx="493776" cy="146304"/>
           </a:xfrm>
           <a:prstGeom prst="rect">
             <a:avLst/>
@@ -3812,14 +3816,14 @@
               <a:buNone/>
             </a:pPr>
             <a:r>
-              <a:rPr lang="en-US" sz="1000" b="1" dirty="0">
+              <a:rPr lang="en-US" sz="1050" b="1" dirty="0">
                 <a:solidFill>
                   <a:srgbClr val="FFFFFF"/>
                 </a:solidFill>
               </a:rPr>
               <a:t>3</a:t>
             </a:r>
-            <a:endParaRPr lang="en-US" sz="1000" dirty="0"/>
+            <a:endParaRPr lang="en-US" sz="1050" dirty="0"/>
           </a:p>
         </p:txBody>
       </p:sp>
@@ -3831,44 +3835,8 @@
         </p:nvSpPr>
         <p:spPr>
           <a:xfrm>
-            <a:off x="6391656" y="2350008"/>
-            <a:ext cx="1097280" cy="228600"/>
-          </a:xfrm>
-          <a:prstGeom prst="rect">
-            <a:avLst/>
-          </a:prstGeom>
-          <a:noFill/>
-          <a:ln/>
-        </p:spPr>
-        <p:txBody>
-          <a:bodyPr wrap="square" lIns="0" tIns="0" rIns="0" bIns="0" rtlCol="0" anchor="ctr"/>
-          <a:lstStyle/>
-          <a:p>
-            <a:pPr indent="0" marL="0">
-              <a:buNone/>
-            </a:pPr>
-            <a:r>
-              <a:rPr lang="en-US" sz="1400" b="1" dirty="0">
-                <a:solidFill>
-                  <a:srgbClr val="18302C"/>
-                </a:solidFill>
-              </a:rPr>
-              <a:t>Разработка</a:t>
-            </a:r>
-            <a:endParaRPr lang="en-US" sz="1400" dirty="0"/>
-          </a:p>
-        </p:txBody>
-      </p:sp>
-      <p:sp>
-        <p:nvSpPr>
-          <p:cNvPr id="20" name="Text 18"/>
-          <p:cNvSpPr/>
-          <p:nvPr/>
-        </p:nvSpPr>
-        <p:spPr>
-          <a:xfrm>
-            <a:off x="5788152" y="2953512"/>
-            <a:ext cx="1700784" cy="201168"/>
+            <a:off x="7150608" y="2304288"/>
+            <a:ext cx="1389888" cy="256032"/>
           </a:xfrm>
           <a:prstGeom prst="rect">
             <a:avLst/>
@@ -3886,14 +3854,52 @@
               <a:buNone/>
             </a:pPr>
             <a:r>
-              <a:rPr lang="en-US" sz="950" dirty="0">
+              <a:rPr lang="en-US" sz="1350" b="1" dirty="0">
+                <a:solidFill>
+                  <a:srgbClr val="18302C"/>
+                </a:solidFill>
+              </a:rPr>
+              <a:t>Разработка</a:t>
+            </a:r>
+            <a:endParaRPr lang="en-US" sz="1350" dirty="0"/>
+          </a:p>
+        </p:txBody>
+      </p:sp>
+      <p:sp>
+        <p:nvSpPr>
+          <p:cNvPr id="20" name="Text 18"/>
+          <p:cNvSpPr/>
+          <p:nvPr/>
+        </p:nvSpPr>
+        <p:spPr>
+          <a:xfrm>
+            <a:off x="6528816" y="2999232"/>
+            <a:ext cx="1956816" cy="228600"/>
+          </a:xfrm>
+          <a:prstGeom prst="rect">
+            <a:avLst/>
+          </a:prstGeom>
+          <a:noFill/>
+          <a:ln/>
+        </p:spPr>
+        <p:txBody>
+          <a:bodyPr wrap="square" lIns="0" tIns="0" rIns="0" bIns="0" rtlCol="0" anchor="ctr">
+            <a:normAutofit/>
+          </a:bodyPr>
+          <a:lstStyle/>
+          <a:p>
+            <a:pPr indent="0" marL="0">
+              <a:buNone/>
+            </a:pPr>
+            <a:r>
+              <a:rPr lang="en-US" sz="1130" dirty="0">
                 <a:solidFill>
                   <a:srgbClr val="60746F"/>
                 </a:solidFill>
               </a:rPr>
               <a:t>код и техдокументация</a:t>
             </a:r>
-            <a:endParaRPr lang="en-US" sz="950" dirty="0"/>
+            <a:endParaRPr lang="en-US" sz="1130" dirty="0"/>
           </a:p>
         </p:txBody>
       </p:sp>
@@ -3905,12 +3911,12 @@
         </p:nvSpPr>
         <p:spPr>
           <a:xfrm>
-            <a:off x="8092440" y="2148840"/>
-            <a:ext cx="2084832" cy="1261872"/>
+            <a:off x="9235440" y="2084832"/>
+            <a:ext cx="2377440" cy="1417320"/>
           </a:xfrm>
           <a:prstGeom prst="roundRect">
             <a:avLst>
-              <a:gd name="adj" fmla="val 5797"/>
+              <a:gd name="adj" fmla="val 5161"/>
             </a:avLst>
           </a:prstGeom>
           <a:solidFill>
@@ -3932,8 +3938,8 @@
         </p:nvSpPr>
         <p:spPr>
           <a:xfrm>
-            <a:off x="8257032" y="2350008"/>
-            <a:ext cx="475488" cy="475488"/>
+            <a:off x="9418320" y="2295144"/>
+            <a:ext cx="493776" cy="493776"/>
           </a:xfrm>
           <a:prstGeom prst="ellipse">
             <a:avLst/>
@@ -3957,8 +3963,8 @@
         </p:nvSpPr>
         <p:spPr>
           <a:xfrm>
-            <a:off x="8257032" y="2478024"/>
-            <a:ext cx="475488" cy="146304"/>
+            <a:off x="9418320" y="2432304"/>
+            <a:ext cx="493776" cy="146304"/>
           </a:xfrm>
           <a:prstGeom prst="rect">
             <a:avLst/>
@@ -3974,14 +3980,14 @@
               <a:buNone/>
             </a:pPr>
             <a:r>
-              <a:rPr lang="en-US" sz="1000" b="1" dirty="0">
+              <a:rPr lang="en-US" sz="1050" b="1" dirty="0">
                 <a:solidFill>
                   <a:srgbClr val="FFFFFF"/>
                 </a:solidFill>
               </a:rPr>
               <a:t>4</a:t>
             </a:r>
-            <a:endParaRPr lang="en-US" sz="1000" dirty="0"/>
+            <a:endParaRPr lang="en-US" sz="1050" dirty="0"/>
           </a:p>
         </p:txBody>
       </p:sp>
@@ -3993,44 +3999,8 @@
         </p:nvSpPr>
         <p:spPr>
           <a:xfrm>
-            <a:off x="8860536" y="2350008"/>
-            <a:ext cx="1097280" cy="228600"/>
-          </a:xfrm>
-          <a:prstGeom prst="rect">
-            <a:avLst/>
-          </a:prstGeom>
-          <a:noFill/>
-          <a:ln/>
-        </p:spPr>
-        <p:txBody>
-          <a:bodyPr wrap="square" lIns="0" tIns="0" rIns="0" bIns="0" rtlCol="0" anchor="ctr"/>
-          <a:lstStyle/>
-          <a:p>
-            <a:pPr indent="0" marL="0">
-              <a:buNone/>
-            </a:pPr>
-            <a:r>
-              <a:rPr lang="en-US" sz="1400" b="1" dirty="0">
-                <a:solidFill>
-                  <a:srgbClr val="18302C"/>
-                </a:solidFill>
-              </a:rPr>
-              <a:t>Финансы</a:t>
-            </a:r>
-            <a:endParaRPr lang="en-US" sz="1400" dirty="0"/>
-          </a:p>
-        </p:txBody>
-      </p:sp>
-      <p:sp>
-        <p:nvSpPr>
-          <p:cNvPr id="25" name="Text 23"/>
-          <p:cNvSpPr/>
-          <p:nvPr/>
-        </p:nvSpPr>
-        <p:spPr>
-          <a:xfrm>
-            <a:off x="8257032" y="2953512"/>
-            <a:ext cx="1700784" cy="201168"/>
+            <a:off x="10040112" y="2304288"/>
+            <a:ext cx="1389888" cy="256032"/>
           </a:xfrm>
           <a:prstGeom prst="rect">
             <a:avLst/>
@@ -4048,14 +4018,52 @@
               <a:buNone/>
             </a:pPr>
             <a:r>
-              <a:rPr lang="en-US" sz="950" dirty="0">
+              <a:rPr lang="en-US" sz="1350" b="1" dirty="0">
+                <a:solidFill>
+                  <a:srgbClr val="18302C"/>
+                </a:solidFill>
+              </a:rPr>
+              <a:t>Финансы</a:t>
+            </a:r>
+            <a:endParaRPr lang="en-US" sz="1350" dirty="0"/>
+          </a:p>
+        </p:txBody>
+      </p:sp>
+      <p:sp>
+        <p:nvSpPr>
+          <p:cNvPr id="25" name="Text 23"/>
+          <p:cNvSpPr/>
+          <p:nvPr/>
+        </p:nvSpPr>
+        <p:spPr>
+          <a:xfrm>
+            <a:off x="9418320" y="2999232"/>
+            <a:ext cx="1956816" cy="228600"/>
+          </a:xfrm>
+          <a:prstGeom prst="rect">
+            <a:avLst/>
+          </a:prstGeom>
+          <a:noFill/>
+          <a:ln/>
+        </p:spPr>
+        <p:txBody>
+          <a:bodyPr wrap="square" lIns="0" tIns="0" rIns="0" bIns="0" rtlCol="0" anchor="ctr">
+            <a:normAutofit/>
+          </a:bodyPr>
+          <a:lstStyle/>
+          <a:p>
+            <a:pPr indent="0" marL="0">
+              <a:buNone/>
+            </a:pPr>
+            <a:r>
+              <a:rPr lang="en-US" sz="1130" dirty="0">
                 <a:solidFill>
                   <a:srgbClr val="60746F"/>
                 </a:solidFill>
               </a:rPr>
               <a:t>аналитика, контроль</a:t>
             </a:r>
-            <a:endParaRPr lang="en-US" sz="950" dirty="0"/>
+            <a:endParaRPr lang="en-US" sz="1130" dirty="0"/>
           </a:p>
         </p:txBody>
       </p:sp>
@@ -4067,12 +4075,12 @@
         </p:nvSpPr>
         <p:spPr>
           <a:xfrm>
-            <a:off x="1920240" y="4160520"/>
-            <a:ext cx="2084832" cy="1261872"/>
+            <a:off x="2011680" y="4041648"/>
+            <a:ext cx="2377440" cy="1417320"/>
           </a:xfrm>
           <a:prstGeom prst="roundRect">
             <a:avLst>
-              <a:gd name="adj" fmla="val 5797"/>
+              <a:gd name="adj" fmla="val 5161"/>
             </a:avLst>
           </a:prstGeom>
           <a:solidFill>
@@ -4094,8 +4102,8 @@
         </p:nvSpPr>
         <p:spPr>
           <a:xfrm>
-            <a:off x="2084832" y="4361688"/>
-            <a:ext cx="475488" cy="475488"/>
+            <a:off x="2194560" y="4251960"/>
+            <a:ext cx="493776" cy="493776"/>
           </a:xfrm>
           <a:prstGeom prst="ellipse">
             <a:avLst/>
@@ -4119,8 +4127,8 @@
         </p:nvSpPr>
         <p:spPr>
           <a:xfrm>
-            <a:off x="2084832" y="4489704"/>
-            <a:ext cx="475488" cy="146304"/>
+            <a:off x="2194560" y="4389120"/>
+            <a:ext cx="493776" cy="146304"/>
           </a:xfrm>
           <a:prstGeom prst="rect">
             <a:avLst/>
@@ -4136,14 +4144,14 @@
               <a:buNone/>
             </a:pPr>
             <a:r>
-              <a:rPr lang="en-US" sz="1000" b="1" dirty="0">
+              <a:rPr lang="en-US" sz="1050" b="1" dirty="0">
                 <a:solidFill>
                   <a:srgbClr val="FFFFFF"/>
                 </a:solidFill>
               </a:rPr>
               <a:t>5</a:t>
             </a:r>
-            <a:endParaRPr lang="en-US" sz="1000" dirty="0"/>
+            <a:endParaRPr lang="en-US" sz="1050" dirty="0"/>
           </a:p>
         </p:txBody>
       </p:sp>
@@ -4155,44 +4163,8 @@
         </p:nvSpPr>
         <p:spPr>
           <a:xfrm>
-            <a:off x="2688336" y="4361688"/>
-            <a:ext cx="1097280" cy="228600"/>
-          </a:xfrm>
-          <a:prstGeom prst="rect">
-            <a:avLst/>
-          </a:prstGeom>
-          <a:noFill/>
-          <a:ln/>
-        </p:spPr>
-        <p:txBody>
-          <a:bodyPr wrap="square" lIns="0" tIns="0" rIns="0" bIns="0" rtlCol="0" anchor="ctr"/>
-          <a:lstStyle/>
-          <a:p>
-            <a:pPr indent="0" marL="0">
-              <a:buNone/>
-            </a:pPr>
-            <a:r>
-              <a:rPr lang="en-US" sz="1400" b="1" dirty="0">
-                <a:solidFill>
-                  <a:srgbClr val="18302C"/>
-                </a:solidFill>
-              </a:rPr>
-              <a:t>Бухгалтерия</a:t>
-            </a:r>
-            <a:endParaRPr lang="en-US" sz="1400" dirty="0"/>
-          </a:p>
-        </p:txBody>
-      </p:sp>
-      <p:sp>
-        <p:nvSpPr>
-          <p:cNvPr id="30" name="Text 28"/>
-          <p:cNvSpPr/>
-          <p:nvPr/>
-        </p:nvSpPr>
-        <p:spPr>
-          <a:xfrm>
-            <a:off x="2084832" y="4965192"/>
-            <a:ext cx="1700784" cy="201168"/>
+            <a:off x="2816352" y="4261104"/>
+            <a:ext cx="1389888" cy="256032"/>
           </a:xfrm>
           <a:prstGeom prst="rect">
             <a:avLst/>
@@ -4210,14 +4182,52 @@
               <a:buNone/>
             </a:pPr>
             <a:r>
-              <a:rPr lang="en-US" sz="950" dirty="0">
+              <a:rPr lang="en-US" sz="1350" b="1" dirty="0">
+                <a:solidFill>
+                  <a:srgbClr val="18302C"/>
+                </a:solidFill>
+              </a:rPr>
+              <a:t>Бухгалтерия</a:t>
+            </a:r>
+            <a:endParaRPr lang="en-US" sz="1350" dirty="0"/>
+          </a:p>
+        </p:txBody>
+      </p:sp>
+      <p:sp>
+        <p:nvSpPr>
+          <p:cNvPr id="30" name="Text 28"/>
+          <p:cNvSpPr/>
+          <p:nvPr/>
+        </p:nvSpPr>
+        <p:spPr>
+          <a:xfrm>
+            <a:off x="2194560" y="4956048"/>
+            <a:ext cx="1956816" cy="228600"/>
+          </a:xfrm>
+          <a:prstGeom prst="rect">
+            <a:avLst/>
+          </a:prstGeom>
+          <a:noFill/>
+          <a:ln/>
+        </p:spPr>
+        <p:txBody>
+          <a:bodyPr wrap="square" lIns="0" tIns="0" rIns="0" bIns="0" rtlCol="0" anchor="ctr">
+            <a:normAutofit/>
+          </a:bodyPr>
+          <a:lstStyle/>
+          <a:p>
+            <a:pPr indent="0" marL="0">
+              <a:buNone/>
+            </a:pPr>
+            <a:r>
+              <a:rPr lang="en-US" sz="1130" dirty="0">
                 <a:solidFill>
                   <a:srgbClr val="60746F"/>
                 </a:solidFill>
               </a:rPr>
               <a:t>первичка, сверки</a:t>
             </a:r>
-            <a:endParaRPr lang="en-US" sz="950" dirty="0"/>
+            <a:endParaRPr lang="en-US" sz="1130" dirty="0"/>
           </a:p>
         </p:txBody>
       </p:sp>
@@ -4229,12 +4239,12 @@
         </p:nvSpPr>
         <p:spPr>
           <a:xfrm>
-            <a:off x="4389120" y="4160520"/>
-            <a:ext cx="2084832" cy="1261872"/>
+            <a:off x="4928616" y="4041648"/>
+            <a:ext cx="2377440" cy="1417320"/>
           </a:xfrm>
           <a:prstGeom prst="roundRect">
             <a:avLst>
-              <a:gd name="adj" fmla="val 5797"/>
+              <a:gd name="adj" fmla="val 5161"/>
             </a:avLst>
           </a:prstGeom>
           <a:solidFill>
@@ -4256,8 +4266,8 @@
         </p:nvSpPr>
         <p:spPr>
           <a:xfrm>
-            <a:off x="4553712" y="4361688"/>
-            <a:ext cx="475488" cy="475488"/>
+            <a:off x="5111496" y="4251960"/>
+            <a:ext cx="493776" cy="493776"/>
           </a:xfrm>
           <a:prstGeom prst="ellipse">
             <a:avLst/>
@@ -4281,8 +4291,8 @@
         </p:nvSpPr>
         <p:spPr>
           <a:xfrm>
-            <a:off x="4553712" y="4489704"/>
-            <a:ext cx="475488" cy="146304"/>
+            <a:off x="5111496" y="4389120"/>
+            <a:ext cx="493776" cy="146304"/>
           </a:xfrm>
           <a:prstGeom prst="rect">
             <a:avLst/>
@@ -4298,14 +4308,14 @@
               <a:buNone/>
             </a:pPr>
             <a:r>
-              <a:rPr lang="en-US" sz="1000" b="1" dirty="0">
+              <a:rPr lang="en-US" sz="1050" b="1" dirty="0">
                 <a:solidFill>
                   <a:srgbClr val="FFFFFF"/>
                 </a:solidFill>
               </a:rPr>
               <a:t>6</a:t>
             </a:r>
-            <a:endParaRPr lang="en-US" sz="1000" dirty="0"/>
+            <a:endParaRPr lang="en-US" sz="1050" dirty="0"/>
           </a:p>
         </p:txBody>
       </p:sp>
@@ -4317,44 +4327,8 @@
         </p:nvSpPr>
         <p:spPr>
           <a:xfrm>
-            <a:off x="5157216" y="4361688"/>
-            <a:ext cx="1097280" cy="228600"/>
-          </a:xfrm>
-          <a:prstGeom prst="rect">
-            <a:avLst/>
-          </a:prstGeom>
-          <a:noFill/>
-          <a:ln/>
-        </p:spPr>
-        <p:txBody>
-          <a:bodyPr wrap="square" lIns="0" tIns="0" rIns="0" bIns="0" rtlCol="0" anchor="ctr"/>
-          <a:lstStyle/>
-          <a:p>
-            <a:pPr indent="0" marL="0">
-              <a:buNone/>
-            </a:pPr>
-            <a:r>
-              <a:rPr lang="en-US" sz="1400" b="1" dirty="0">
-                <a:solidFill>
-                  <a:srgbClr val="18302C"/>
-                </a:solidFill>
-              </a:rPr>
-              <a:t>PR</a:t>
-            </a:r>
-            <a:endParaRPr lang="en-US" sz="1400" dirty="0"/>
-          </a:p>
-        </p:txBody>
-      </p:sp>
-      <p:sp>
-        <p:nvSpPr>
-          <p:cNvPr id="35" name="Text 33"/>
-          <p:cNvSpPr/>
-          <p:nvPr/>
-        </p:nvSpPr>
-        <p:spPr>
-          <a:xfrm>
-            <a:off x="4553712" y="4965192"/>
-            <a:ext cx="1700784" cy="201168"/>
+            <a:off x="5733288" y="4261104"/>
+            <a:ext cx="1389888" cy="256032"/>
           </a:xfrm>
           <a:prstGeom prst="rect">
             <a:avLst/>
@@ -4372,14 +4346,52 @@
               <a:buNone/>
             </a:pPr>
             <a:r>
-              <a:rPr lang="en-US" sz="950" dirty="0">
+              <a:rPr lang="en-US" sz="1350" b="1" dirty="0">
+                <a:solidFill>
+                  <a:srgbClr val="18302C"/>
+                </a:solidFill>
+              </a:rPr>
+              <a:t>PR</a:t>
+            </a:r>
+            <a:endParaRPr lang="en-US" sz="1350" dirty="0"/>
+          </a:p>
+        </p:txBody>
+      </p:sp>
+      <p:sp>
+        <p:nvSpPr>
+          <p:cNvPr id="35" name="Text 33"/>
+          <p:cNvSpPr/>
+          <p:nvPr/>
+        </p:nvSpPr>
+        <p:spPr>
+          <a:xfrm>
+            <a:off x="5111496" y="4956048"/>
+            <a:ext cx="1956816" cy="228600"/>
+          </a:xfrm>
+          <a:prstGeom prst="rect">
+            <a:avLst/>
+          </a:prstGeom>
+          <a:noFill/>
+          <a:ln/>
+        </p:spPr>
+        <p:txBody>
+          <a:bodyPr wrap="square" lIns="0" tIns="0" rIns="0" bIns="0" rtlCol="0" anchor="ctr">
+            <a:normAutofit/>
+          </a:bodyPr>
+          <a:lstStyle/>
+          <a:p>
+            <a:pPr indent="0" marL="0">
+              <a:buNone/>
+            </a:pPr>
+            <a:r>
+              <a:rPr lang="en-US" sz="1130" dirty="0">
                 <a:solidFill>
                   <a:srgbClr val="60746F"/>
                 </a:solidFill>
               </a:rPr>
               <a:t>контент, мониторинг</a:t>
             </a:r>
-            <a:endParaRPr lang="en-US" sz="950" dirty="0"/>
+            <a:endParaRPr lang="en-US" sz="1130" dirty="0"/>
           </a:p>
         </p:txBody>
       </p:sp>
@@ -4391,12 +4403,12 @@
         </p:nvSpPr>
         <p:spPr>
           <a:xfrm>
-            <a:off x="6858000" y="4160520"/>
-            <a:ext cx="2084832" cy="1261872"/>
+            <a:off x="7845552" y="4041648"/>
+            <a:ext cx="2377440" cy="1417320"/>
           </a:xfrm>
           <a:prstGeom prst="roundRect">
             <a:avLst>
-              <a:gd name="adj" fmla="val 5797"/>
+              <a:gd name="adj" fmla="val 5161"/>
             </a:avLst>
           </a:prstGeom>
           <a:solidFill>
@@ -4418,8 +4430,8 @@
         </p:nvSpPr>
         <p:spPr>
           <a:xfrm>
-            <a:off x="7022592" y="4361688"/>
-            <a:ext cx="475488" cy="475488"/>
+            <a:off x="8028432" y="4251960"/>
+            <a:ext cx="493776" cy="493776"/>
           </a:xfrm>
           <a:prstGeom prst="ellipse">
             <a:avLst/>
@@ -4443,8 +4455,8 @@
         </p:nvSpPr>
         <p:spPr>
           <a:xfrm>
-            <a:off x="7022592" y="4489704"/>
-            <a:ext cx="475488" cy="146304"/>
+            <a:off x="8028432" y="4389120"/>
+            <a:ext cx="493776" cy="146304"/>
           </a:xfrm>
           <a:prstGeom prst="rect">
             <a:avLst/>
@@ -4460,14 +4472,14 @@
               <a:buNone/>
             </a:pPr>
             <a:r>
-              <a:rPr lang="en-US" sz="1000" b="1" dirty="0">
+              <a:rPr lang="en-US" sz="1050" b="1" dirty="0">
                 <a:solidFill>
                   <a:srgbClr val="FFFFFF"/>
                 </a:solidFill>
               </a:rPr>
               <a:t>7</a:t>
             </a:r>
-            <a:endParaRPr lang="en-US" sz="1000" dirty="0"/>
+            <a:endParaRPr lang="en-US" sz="1050" dirty="0"/>
           </a:p>
         </p:txBody>
       </p:sp>
@@ -4479,44 +4491,8 @@
         </p:nvSpPr>
         <p:spPr>
           <a:xfrm>
-            <a:off x="7626096" y="4361688"/>
-            <a:ext cx="1097280" cy="228600"/>
-          </a:xfrm>
-          <a:prstGeom prst="rect">
-            <a:avLst/>
-          </a:prstGeom>
-          <a:noFill/>
-          <a:ln/>
-        </p:spPr>
-        <p:txBody>
-          <a:bodyPr wrap="square" lIns="0" tIns="0" rIns="0" bIns="0" rtlCol="0" anchor="ctr"/>
-          <a:lstStyle/>
-          <a:p>
-            <a:pPr indent="0" marL="0">
-              <a:buNone/>
-            </a:pPr>
-            <a:r>
-              <a:rPr lang="en-US" sz="1400" b="1" dirty="0">
-                <a:solidFill>
-                  <a:srgbClr val="18302C"/>
-                </a:solidFill>
-              </a:rPr>
-              <a:t>GR</a:t>
-            </a:r>
-            <a:endParaRPr lang="en-US" sz="1400" dirty="0"/>
-          </a:p>
-        </p:txBody>
-      </p:sp>
-      <p:sp>
-        <p:nvSpPr>
-          <p:cNvPr id="40" name="Text 38"/>
-          <p:cNvSpPr/>
-          <p:nvPr/>
-        </p:nvSpPr>
-        <p:spPr>
-          <a:xfrm>
-            <a:off x="7022592" y="4965192"/>
-            <a:ext cx="1700784" cy="201168"/>
+            <a:off x="8650224" y="4261104"/>
+            <a:ext cx="1389888" cy="256032"/>
           </a:xfrm>
           <a:prstGeom prst="rect">
             <a:avLst/>
@@ -4534,14 +4510,52 @@
               <a:buNone/>
             </a:pPr>
             <a:r>
-              <a:rPr lang="en-US" sz="950" dirty="0">
+              <a:rPr lang="en-US" sz="1350" b="1" dirty="0">
+                <a:solidFill>
+                  <a:srgbClr val="18302C"/>
+                </a:solidFill>
+              </a:rPr>
+              <a:t>GR</a:t>
+            </a:r>
+            <a:endParaRPr lang="en-US" sz="1350" dirty="0"/>
+          </a:p>
+        </p:txBody>
+      </p:sp>
+      <p:sp>
+        <p:nvSpPr>
+          <p:cNvPr id="40" name="Text 38"/>
+          <p:cNvSpPr/>
+          <p:nvPr/>
+        </p:nvSpPr>
+        <p:spPr>
+          <a:xfrm>
+            <a:off x="8028432" y="4956048"/>
+            <a:ext cx="1956816" cy="228600"/>
+          </a:xfrm>
+          <a:prstGeom prst="rect">
+            <a:avLst/>
+          </a:prstGeom>
+          <a:noFill/>
+          <a:ln/>
+        </p:spPr>
+        <p:txBody>
+          <a:bodyPr wrap="square" lIns="0" tIns="0" rIns="0" bIns="0" rtlCol="0" anchor="ctr">
+            <a:normAutofit/>
+          </a:bodyPr>
+          <a:lstStyle/>
+          <a:p>
+            <a:pPr indent="0" marL="0">
+              <a:buNone/>
+            </a:pPr>
+            <a:r>
+              <a:rPr lang="en-US" sz="1130" dirty="0">
                 <a:solidFill>
                   <a:srgbClr val="60746F"/>
                 </a:solidFill>
               </a:rPr>
               <a:t>НПА, справки</a:t>
             </a:r>
-            <a:endParaRPr lang="en-US" sz="950" dirty="0"/>
+            <a:endParaRPr lang="en-US" sz="1130" dirty="0"/>
           </a:p>
         </p:txBody>
       </p:sp>
@@ -5464,10 +5478,44 @@
         </p:nvSpPr>
         <p:spPr>
           <a:xfrm>
-            <a:off x="530352" y="2423160"/>
-            <a:ext cx="694944" cy="694944"/>
-          </a:xfrm>
-          <a:prstGeom prst="ellipse">
+            <a:off x="658368" y="2084832"/>
+            <a:ext cx="3419856" cy="1298448"/>
+          </a:xfrm>
+          <a:prstGeom prst="roundRect">
+            <a:avLst>
+              <a:gd name="adj" fmla="val 5634"/>
+            </a:avLst>
+          </a:prstGeom>
+          <a:solidFill>
+            <a:srgbClr val="FFFFFF"/>
+          </a:solidFill>
+          <a:ln w="8890">
+            <a:solidFill>
+              <a:srgbClr val="D7E1DE"/>
+            </a:solidFill>
+            <a:prstDash val="solid"/>
+          </a:ln>
+          <a:effectLst>
+            <a:outerShdw sx="100000" sy="100000" kx="0" ky="0" algn="bl" rotWithShape="0" blurRad="25400" dist="50800" dir="2700000">
+              <a:srgbClr val="6B827B">
+                <a:alpha val="10000"/>
+              </a:srgbClr>
+            </a:outerShdw>
+          </a:effectLst>
+        </p:spPr>
+      </p:sp>
+      <p:sp>
+        <p:nvSpPr>
+          <p:cNvPr id="7" name="Shape 5"/>
+          <p:cNvSpPr/>
+          <p:nvPr/>
+        </p:nvSpPr>
+        <p:spPr>
+          <a:xfrm>
+            <a:off x="658368" y="2084832"/>
+            <a:ext cx="91440" cy="1298448"/>
+          </a:xfrm>
+          <a:prstGeom prst="rect">
             <a:avLst/>
           </a:prstGeom>
           <a:solidFill>
@@ -5483,189 +5531,140 @@
       </p:sp>
       <p:sp>
         <p:nvSpPr>
-          <p:cNvPr id="7" name="Text 5"/>
-          <p:cNvSpPr/>
-          <p:nvPr/>
-        </p:nvSpPr>
-        <p:spPr>
-          <a:xfrm>
-            <a:off x="530352" y="2633472"/>
-            <a:ext cx="694944" cy="164592"/>
-          </a:xfrm>
-          <a:prstGeom prst="rect">
-            <a:avLst/>
-          </a:prstGeom>
-          <a:noFill/>
-          <a:ln/>
-        </p:spPr>
-        <p:txBody>
-          <a:bodyPr wrap="square" lIns="0" tIns="0" rIns="0" bIns="0" rtlCol="0" anchor="ctr"/>
-          <a:lstStyle/>
-          <a:p>
-            <a:pPr algn="ctr" indent="0" marL="0">
-              <a:buNone/>
-            </a:pPr>
-            <a:r>
-              <a:rPr lang="en-US" sz="1000" b="1" dirty="0">
-                <a:solidFill>
-                  <a:srgbClr val="FFFFFF"/>
-                </a:solidFill>
-              </a:rPr>
-              <a:t>G0</a:t>
-            </a:r>
-            <a:endParaRPr lang="en-US" sz="1000" dirty="0"/>
-          </a:p>
-        </p:txBody>
-      </p:sp>
-      <p:sp>
-        <p:nvSpPr>
-          <p:cNvPr id="8" name="Shape 6"/>
-          <p:cNvSpPr/>
-          <p:nvPr/>
-        </p:nvSpPr>
-        <p:spPr>
-          <a:xfrm>
-            <a:off x="1243584" y="2761488"/>
-            <a:ext cx="1078992" cy="0"/>
-          </a:xfrm>
-          <a:prstGeom prst="line">
-            <a:avLst/>
-          </a:prstGeom>
-          <a:noFill/>
-          <a:ln w="25400">
+          <p:cNvPr id="8" name="Text 6"/>
+          <p:cNvSpPr/>
+          <p:nvPr/>
+        </p:nvSpPr>
+        <p:spPr>
+          <a:xfrm>
+            <a:off x="886968" y="2258568"/>
+            <a:ext cx="3035808" cy="310896"/>
+          </a:xfrm>
+          <a:prstGeom prst="rect">
+            <a:avLst/>
+          </a:prstGeom>
+          <a:noFill/>
+          <a:ln/>
+        </p:spPr>
+        <p:txBody>
+          <a:bodyPr wrap="square" lIns="0" tIns="0" rIns="0" bIns="0" rtlCol="0" anchor="ctr">
+            <a:normAutofit/>
+          </a:bodyPr>
+          <a:lstStyle/>
+          <a:p>
+            <a:pPr indent="0" marL="0">
+              <a:buNone/>
+            </a:pPr>
+            <a:r>
+              <a:rPr lang="en-US" sz="1400" b="1" dirty="0">
+                <a:solidFill>
+                  <a:srgbClr val="18302C"/>
+                </a:solidFill>
+              </a:rPr>
+              <a:t>G0 · Защита</a:t>
+            </a:r>
+            <a:endParaRPr lang="en-US" sz="1400" dirty="0"/>
+          </a:p>
+        </p:txBody>
+      </p:sp>
+      <p:sp>
+        <p:nvSpPr>
+          <p:cNvPr id="9" name="Text 7"/>
+          <p:cNvSpPr/>
+          <p:nvPr/>
+        </p:nvSpPr>
+        <p:spPr>
+          <a:xfrm>
+            <a:off x="886968" y="2688336"/>
+            <a:ext cx="3035808" cy="530352"/>
+          </a:xfrm>
+          <a:prstGeom prst="rect">
+            <a:avLst/>
+          </a:prstGeom>
+          <a:noFill/>
+          <a:ln/>
+        </p:spPr>
+        <p:txBody>
+          <a:bodyPr wrap="square" lIns="254" tIns="254" rIns="254" bIns="254" rtlCol="0" anchor="t">
+            <a:normAutofit/>
+          </a:bodyPr>
+          <a:lstStyle/>
+          <a:p>
+            <a:pPr indent="0" marL="0">
+              <a:buNone/>
+            </a:pPr>
+            <a:r>
+              <a:rPr lang="en-US" sz="1130" dirty="0">
+                <a:solidFill>
+                  <a:srgbClr val="60746F"/>
+                </a:solidFill>
+              </a:rPr>
+              <a:t>до T0</a:t>
+            </a:r>
+            <a:endParaRPr lang="en-US" sz="1130" dirty="0"/>
+          </a:p>
+          <a:p>
+            <a:pPr indent="0" marL="0">
+              <a:buNone/>
+            </a:pPr>
+            <a:r>
+              <a:rPr lang="en-US" sz="1130" dirty="0">
+                <a:solidFill>
+                  <a:srgbClr val="60746F"/>
+                </a:solidFill>
+              </a:rPr>
+              <a:t>решение УК</a:t>
+            </a:r>
+            <a:endParaRPr lang="en-US" sz="1130" dirty="0"/>
+          </a:p>
+        </p:txBody>
+      </p:sp>
+      <p:sp>
+        <p:nvSpPr>
+          <p:cNvPr id="10" name="Shape 8"/>
+          <p:cNvSpPr/>
+          <p:nvPr/>
+        </p:nvSpPr>
+        <p:spPr>
+          <a:xfrm>
+            <a:off x="4370832" y="2084832"/>
+            <a:ext cx="3419856" cy="1298448"/>
+          </a:xfrm>
+          <a:prstGeom prst="roundRect">
+            <a:avLst>
+              <a:gd name="adj" fmla="val 5634"/>
+            </a:avLst>
+          </a:prstGeom>
+          <a:solidFill>
+            <a:srgbClr val="FFFFFF"/>
+          </a:solidFill>
+          <a:ln w="8890">
             <a:solidFill>
-              <a:srgbClr val="BDE3D7"/>
+              <a:srgbClr val="D7E1DE"/>
             </a:solidFill>
             <a:prstDash val="solid"/>
           </a:ln>
-        </p:spPr>
-      </p:sp>
-      <p:sp>
-        <p:nvSpPr>
-          <p:cNvPr id="9" name="Text 7"/>
-          <p:cNvSpPr/>
-          <p:nvPr/>
-        </p:nvSpPr>
-        <p:spPr>
-          <a:xfrm>
-            <a:off x="374904" y="3401568"/>
-            <a:ext cx="1024128" cy="256032"/>
-          </a:xfrm>
-          <a:prstGeom prst="rect">
-            <a:avLst/>
-          </a:prstGeom>
-          <a:noFill/>
-          <a:ln/>
-        </p:spPr>
-        <p:txBody>
-          <a:bodyPr wrap="square" lIns="0" tIns="0" rIns="0" bIns="0" rtlCol="0" anchor="ctr">
-            <a:normAutofit/>
-          </a:bodyPr>
-          <a:lstStyle/>
-          <a:p>
-            <a:pPr algn="ctr" indent="0" marL="0">
-              <a:buNone/>
-            </a:pPr>
-            <a:r>
-              <a:rPr lang="en-US" sz="1150" b="1" dirty="0">
-                <a:solidFill>
-                  <a:srgbClr val="18302C"/>
-                </a:solidFill>
-              </a:rPr>
-              <a:t>Защита</a:t>
-            </a:r>
-            <a:endParaRPr lang="en-US" sz="1150" dirty="0"/>
-          </a:p>
-        </p:txBody>
-      </p:sp>
-      <p:sp>
-        <p:nvSpPr>
-          <p:cNvPr id="10" name="Text 8"/>
-          <p:cNvSpPr/>
-          <p:nvPr/>
-        </p:nvSpPr>
-        <p:spPr>
-          <a:xfrm>
-            <a:off x="283464" y="3794760"/>
-            <a:ext cx="1207008" cy="210312"/>
-          </a:xfrm>
-          <a:prstGeom prst="rect">
-            <a:avLst/>
-          </a:prstGeom>
-          <a:noFill/>
-          <a:ln/>
-        </p:spPr>
-        <p:txBody>
-          <a:bodyPr wrap="square" lIns="0" tIns="0" rIns="0" bIns="0" rtlCol="0" anchor="ctr">
-            <a:normAutofit/>
-          </a:bodyPr>
-          <a:lstStyle/>
-          <a:p>
-            <a:pPr algn="ctr" indent="0" marL="0">
-              <a:buNone/>
-            </a:pPr>
-            <a:r>
-              <a:rPr lang="en-US" sz="950" b="1" dirty="0">
-                <a:solidFill>
-                  <a:srgbClr val="2F8B7B"/>
-                </a:solidFill>
-              </a:rPr>
-              <a:t>до T0</a:t>
-            </a:r>
-            <a:endParaRPr lang="en-US" sz="950" dirty="0"/>
-          </a:p>
-        </p:txBody>
-      </p:sp>
-      <p:sp>
-        <p:nvSpPr>
-          <p:cNvPr id="11" name="Text 9"/>
-          <p:cNvSpPr/>
-          <p:nvPr/>
-        </p:nvSpPr>
-        <p:spPr>
-          <a:xfrm>
-            <a:off x="256032" y="4151376"/>
-            <a:ext cx="1261872" cy="347472"/>
-          </a:xfrm>
-          <a:prstGeom prst="rect">
-            <a:avLst/>
-          </a:prstGeom>
-          <a:noFill/>
-          <a:ln/>
-        </p:spPr>
-        <p:txBody>
-          <a:bodyPr wrap="square" lIns="0" tIns="0" rIns="0" bIns="0" rtlCol="0" anchor="ctr">
-            <a:normAutofit/>
-          </a:bodyPr>
-          <a:lstStyle/>
-          <a:p>
-            <a:pPr algn="ctr" indent="0" marL="0">
-              <a:buNone/>
-            </a:pPr>
-            <a:r>
-              <a:rPr lang="en-US" sz="920" dirty="0">
-                <a:solidFill>
-                  <a:srgbClr val="60746F"/>
-                </a:solidFill>
-              </a:rPr>
-              <a:t>решение УК</a:t>
-            </a:r>
-            <a:endParaRPr lang="en-US" sz="920" dirty="0"/>
-          </a:p>
-        </p:txBody>
-      </p:sp>
-      <p:sp>
-        <p:nvSpPr>
-          <p:cNvPr id="12" name="Shape 10"/>
-          <p:cNvSpPr/>
-          <p:nvPr/>
-        </p:nvSpPr>
-        <p:spPr>
-          <a:xfrm>
-            <a:off x="2331720" y="2423160"/>
-            <a:ext cx="694944" cy="694944"/>
-          </a:xfrm>
-          <a:prstGeom prst="ellipse">
+          <a:effectLst>
+            <a:outerShdw sx="100000" sy="100000" kx="0" ky="0" algn="bl" rotWithShape="0" blurRad="25400" dist="50800" dir="2700000">
+              <a:srgbClr val="6B827B">
+                <a:alpha val="10000"/>
+              </a:srgbClr>
+            </a:outerShdw>
+          </a:effectLst>
+        </p:spPr>
+      </p:sp>
+      <p:sp>
+        <p:nvSpPr>
+          <p:cNvPr id="11" name="Shape 9"/>
+          <p:cNvSpPr/>
+          <p:nvPr/>
+        </p:nvSpPr>
+        <p:spPr>
+          <a:xfrm>
+            <a:off x="4370832" y="2084832"/>
+            <a:ext cx="91440" cy="1298448"/>
+          </a:xfrm>
+          <a:prstGeom prst="rect">
             <a:avLst/>
           </a:prstGeom>
           <a:solidFill>
@@ -5681,37 +5680,91 @@
       </p:sp>
       <p:sp>
         <p:nvSpPr>
+          <p:cNvPr id="12" name="Text 10"/>
+          <p:cNvSpPr/>
+          <p:nvPr/>
+        </p:nvSpPr>
+        <p:spPr>
+          <a:xfrm>
+            <a:off x="4599432" y="2258568"/>
+            <a:ext cx="3035808" cy="310896"/>
+          </a:xfrm>
+          <a:prstGeom prst="rect">
+            <a:avLst/>
+          </a:prstGeom>
+          <a:noFill/>
+          <a:ln/>
+        </p:spPr>
+        <p:txBody>
+          <a:bodyPr wrap="square" lIns="0" tIns="0" rIns="0" bIns="0" rtlCol="0" anchor="ctr">
+            <a:normAutofit/>
+          </a:bodyPr>
+          <a:lstStyle/>
+          <a:p>
+            <a:pPr indent="0" marL="0">
+              <a:buNone/>
+            </a:pPr>
+            <a:r>
+              <a:rPr lang="en-US" sz="1400" b="1" dirty="0">
+                <a:solidFill>
+                  <a:srgbClr val="18302C"/>
+                </a:solidFill>
+              </a:rPr>
+              <a:t>1 · Мобилизация</a:t>
+            </a:r>
+            <a:endParaRPr lang="en-US" sz="1400" dirty="0"/>
+          </a:p>
+        </p:txBody>
+      </p:sp>
+      <p:sp>
+        <p:nvSpPr>
           <p:cNvPr id="13" name="Text 11"/>
           <p:cNvSpPr/>
           <p:nvPr/>
         </p:nvSpPr>
         <p:spPr>
           <a:xfrm>
-            <a:off x="2331720" y="2633472"/>
-            <a:ext cx="694944" cy="164592"/>
-          </a:xfrm>
-          <a:prstGeom prst="rect">
-            <a:avLst/>
-          </a:prstGeom>
-          <a:noFill/>
-          <a:ln/>
-        </p:spPr>
-        <p:txBody>
-          <a:bodyPr wrap="square" lIns="0" tIns="0" rIns="0" bIns="0" rtlCol="0" anchor="ctr"/>
-          <a:lstStyle/>
-          <a:p>
-            <a:pPr algn="ctr" indent="0" marL="0">
-              <a:buNone/>
-            </a:pPr>
-            <a:r>
-              <a:rPr lang="en-US" sz="1000" b="1" dirty="0">
-                <a:solidFill>
-                  <a:srgbClr val="FFFFFF"/>
-                </a:solidFill>
-              </a:rPr>
-              <a:t>1</a:t>
-            </a:r>
-            <a:endParaRPr lang="en-US" sz="1000" dirty="0"/>
+            <a:off x="4599432" y="2688336"/>
+            <a:ext cx="3035808" cy="530352"/>
+          </a:xfrm>
+          <a:prstGeom prst="rect">
+            <a:avLst/>
+          </a:prstGeom>
+          <a:noFill/>
+          <a:ln/>
+        </p:spPr>
+        <p:txBody>
+          <a:bodyPr wrap="square" lIns="254" tIns="254" rIns="254" bIns="254" rtlCol="0" anchor="t">
+            <a:normAutofit/>
+          </a:bodyPr>
+          <a:lstStyle/>
+          <a:p>
+            <a:pPr indent="0" marL="0">
+              <a:buNone/>
+            </a:pPr>
+            <a:r>
+              <a:rPr lang="en-US" sz="1130" dirty="0">
+                <a:solidFill>
+                  <a:srgbClr val="60746F"/>
+                </a:solidFill>
+              </a:rPr>
+              <a:t>T0 + 0–2 недели</a:t>
+            </a:r>
+            <a:endParaRPr lang="en-US" sz="1130" dirty="0"/>
+          </a:p>
+          <a:p>
+            <a:pPr indent="0" marL="0">
+              <a:buNone/>
+            </a:pPr>
+            <a:r>
+              <a:rPr lang="en-US" sz="1130" dirty="0">
+                <a:solidFill>
+                  <a:srgbClr val="60746F"/>
+                </a:solidFill>
+              </a:rPr>
+              <a:t>роли и план</a:t>
+            </a:r>
+            <a:endParaRPr lang="en-US" sz="1130" dirty="0"/>
           </a:p>
         </p:txBody>
       </p:sp>
@@ -5723,147 +5776,44 @@
         </p:nvSpPr>
         <p:spPr>
           <a:xfrm>
-            <a:off x="3044952" y="2761488"/>
-            <a:ext cx="1078992" cy="0"/>
-          </a:xfrm>
-          <a:prstGeom prst="line">
-            <a:avLst/>
-          </a:prstGeom>
-          <a:noFill/>
-          <a:ln w="25400">
+            <a:off x="8083296" y="2084832"/>
+            <a:ext cx="3419856" cy="1298448"/>
+          </a:xfrm>
+          <a:prstGeom prst="roundRect">
+            <a:avLst>
+              <a:gd name="adj" fmla="val 5634"/>
+            </a:avLst>
+          </a:prstGeom>
+          <a:solidFill>
+            <a:srgbClr val="FFFFFF"/>
+          </a:solidFill>
+          <a:ln w="8890">
             <a:solidFill>
-              <a:srgbClr val="BDE3D7"/>
+              <a:srgbClr val="D7E1DE"/>
             </a:solidFill>
             <a:prstDash val="solid"/>
           </a:ln>
-        </p:spPr>
-      </p:sp>
-      <p:sp>
-        <p:nvSpPr>
-          <p:cNvPr id="15" name="Text 13"/>
-          <p:cNvSpPr/>
-          <p:nvPr/>
-        </p:nvSpPr>
-        <p:spPr>
-          <a:xfrm>
-            <a:off x="2176272" y="3401568"/>
-            <a:ext cx="1024128" cy="256032"/>
-          </a:xfrm>
-          <a:prstGeom prst="rect">
-            <a:avLst/>
-          </a:prstGeom>
-          <a:noFill/>
-          <a:ln/>
-        </p:spPr>
-        <p:txBody>
-          <a:bodyPr wrap="square" lIns="0" tIns="0" rIns="0" bIns="0" rtlCol="0" anchor="ctr">
-            <a:normAutofit/>
-          </a:bodyPr>
-          <a:lstStyle/>
-          <a:p>
-            <a:pPr algn="ctr" indent="0" marL="0">
-              <a:buNone/>
-            </a:pPr>
-            <a:r>
-              <a:rPr lang="en-US" sz="1150" b="1" dirty="0">
-                <a:solidFill>
-                  <a:srgbClr val="18302C"/>
-                </a:solidFill>
-              </a:rPr>
-              <a:t>Мобилизация</a:t>
-            </a:r>
-            <a:endParaRPr lang="en-US" sz="1150" dirty="0"/>
-          </a:p>
-        </p:txBody>
-      </p:sp>
-      <p:sp>
-        <p:nvSpPr>
-          <p:cNvPr id="16" name="Text 14"/>
-          <p:cNvSpPr/>
-          <p:nvPr/>
-        </p:nvSpPr>
-        <p:spPr>
-          <a:xfrm>
-            <a:off x="2084832" y="3794760"/>
-            <a:ext cx="1207008" cy="210312"/>
-          </a:xfrm>
-          <a:prstGeom prst="rect">
-            <a:avLst/>
-          </a:prstGeom>
-          <a:noFill/>
-          <a:ln/>
-        </p:spPr>
-        <p:txBody>
-          <a:bodyPr wrap="square" lIns="0" tIns="0" rIns="0" bIns="0" rtlCol="0" anchor="ctr">
-            <a:normAutofit/>
-          </a:bodyPr>
-          <a:lstStyle/>
-          <a:p>
-            <a:pPr algn="ctr" indent="0" marL="0">
-              <a:buNone/>
-            </a:pPr>
-            <a:r>
-              <a:rPr lang="en-US" sz="950" b="1" dirty="0">
-                <a:solidFill>
-                  <a:srgbClr val="2F8B7B"/>
-                </a:solidFill>
-              </a:rPr>
-              <a:t>T0 + 0–2</a:t>
-            </a:r>
-            <a:endParaRPr lang="en-US" sz="950" dirty="0"/>
-          </a:p>
-        </p:txBody>
-      </p:sp>
-      <p:sp>
-        <p:nvSpPr>
-          <p:cNvPr id="17" name="Text 15"/>
-          <p:cNvSpPr/>
-          <p:nvPr/>
-        </p:nvSpPr>
-        <p:spPr>
-          <a:xfrm>
-            <a:off x="2057400" y="4151376"/>
-            <a:ext cx="1261872" cy="347472"/>
-          </a:xfrm>
-          <a:prstGeom prst="rect">
-            <a:avLst/>
-          </a:prstGeom>
-          <a:noFill/>
-          <a:ln/>
-        </p:spPr>
-        <p:txBody>
-          <a:bodyPr wrap="square" lIns="0" tIns="0" rIns="0" bIns="0" rtlCol="0" anchor="ctr">
-            <a:normAutofit/>
-          </a:bodyPr>
-          <a:lstStyle/>
-          <a:p>
-            <a:pPr algn="ctr" indent="0" marL="0">
-              <a:buNone/>
-            </a:pPr>
-            <a:r>
-              <a:rPr lang="en-US" sz="920" dirty="0">
-                <a:solidFill>
-                  <a:srgbClr val="60746F"/>
-                </a:solidFill>
-              </a:rPr>
-              <a:t>роли и план</a:t>
-            </a:r>
-            <a:endParaRPr lang="en-US" sz="920" dirty="0"/>
-          </a:p>
-        </p:txBody>
-      </p:sp>
-      <p:sp>
-        <p:nvSpPr>
-          <p:cNvPr id="18" name="Shape 16"/>
-          <p:cNvSpPr/>
-          <p:nvPr/>
-        </p:nvSpPr>
-        <p:spPr>
-          <a:xfrm>
-            <a:off x="4261104" y="2423160"/>
-            <a:ext cx="694944" cy="694944"/>
-          </a:xfrm>
-          <a:prstGeom prst="ellipse">
+          <a:effectLst>
+            <a:outerShdw sx="100000" sy="100000" kx="0" ky="0" algn="bl" rotWithShape="0" blurRad="25400" dist="50800" dir="2700000">
+              <a:srgbClr val="6B827B">
+                <a:alpha val="10000"/>
+              </a:srgbClr>
+            </a:outerShdw>
+          </a:effectLst>
+        </p:spPr>
+      </p:sp>
+      <p:sp>
+        <p:nvSpPr>
+          <p:cNvPr id="15" name="Shape 13"/>
+          <p:cNvSpPr/>
+          <p:nvPr/>
+        </p:nvSpPr>
+        <p:spPr>
+          <a:xfrm>
+            <a:off x="8083296" y="2084832"/>
+            <a:ext cx="91440" cy="1298448"/>
+          </a:xfrm>
+          <a:prstGeom prst="rect">
             <a:avLst/>
           </a:prstGeom>
           <a:solidFill>
@@ -5879,189 +5829,140 @@
       </p:sp>
       <p:sp>
         <p:nvSpPr>
-          <p:cNvPr id="19" name="Text 17"/>
-          <p:cNvSpPr/>
-          <p:nvPr/>
-        </p:nvSpPr>
-        <p:spPr>
-          <a:xfrm>
-            <a:off x="4261104" y="2633472"/>
-            <a:ext cx="694944" cy="164592"/>
-          </a:xfrm>
-          <a:prstGeom prst="rect">
-            <a:avLst/>
-          </a:prstGeom>
-          <a:noFill/>
-          <a:ln/>
-        </p:spPr>
-        <p:txBody>
-          <a:bodyPr wrap="square" lIns="0" tIns="0" rIns="0" bIns="0" rtlCol="0" anchor="ctr"/>
-          <a:lstStyle/>
-          <a:p>
-            <a:pPr algn="ctr" indent="0" marL="0">
-              <a:buNone/>
-            </a:pPr>
-            <a:r>
-              <a:rPr lang="en-US" sz="1000" b="1" dirty="0">
-                <a:solidFill>
-                  <a:srgbClr val="FFFFFF"/>
-                </a:solidFill>
-              </a:rPr>
-              <a:t>2</a:t>
-            </a:r>
-            <a:endParaRPr lang="en-US" sz="1000" dirty="0"/>
-          </a:p>
-        </p:txBody>
-      </p:sp>
-      <p:sp>
-        <p:nvSpPr>
-          <p:cNvPr id="20" name="Shape 18"/>
-          <p:cNvSpPr/>
-          <p:nvPr/>
-        </p:nvSpPr>
-        <p:spPr>
-          <a:xfrm>
-            <a:off x="4974336" y="2761488"/>
-            <a:ext cx="1078992" cy="0"/>
-          </a:xfrm>
-          <a:prstGeom prst="line">
-            <a:avLst/>
-          </a:prstGeom>
-          <a:noFill/>
-          <a:ln w="25400">
+          <p:cNvPr id="16" name="Text 14"/>
+          <p:cNvSpPr/>
+          <p:nvPr/>
+        </p:nvSpPr>
+        <p:spPr>
+          <a:xfrm>
+            <a:off x="8311896" y="2258568"/>
+            <a:ext cx="3035808" cy="310896"/>
+          </a:xfrm>
+          <a:prstGeom prst="rect">
+            <a:avLst/>
+          </a:prstGeom>
+          <a:noFill/>
+          <a:ln/>
+        </p:spPr>
+        <p:txBody>
+          <a:bodyPr wrap="square" lIns="0" tIns="0" rIns="0" bIns="0" rtlCol="0" anchor="ctr">
+            <a:normAutofit/>
+          </a:bodyPr>
+          <a:lstStyle/>
+          <a:p>
+            <a:pPr indent="0" marL="0">
+              <a:buNone/>
+            </a:pPr>
+            <a:r>
+              <a:rPr lang="en-US" sz="1400" b="1" dirty="0">
+                <a:solidFill>
+                  <a:srgbClr val="18302C"/>
+                </a:solidFill>
+              </a:rPr>
+              <a:t>2 · Диагностика</a:t>
+            </a:r>
+            <a:endParaRPr lang="en-US" sz="1400" dirty="0"/>
+          </a:p>
+        </p:txBody>
+      </p:sp>
+      <p:sp>
+        <p:nvSpPr>
+          <p:cNvPr id="17" name="Text 15"/>
+          <p:cNvSpPr/>
+          <p:nvPr/>
+        </p:nvSpPr>
+        <p:spPr>
+          <a:xfrm>
+            <a:off x="8311896" y="2688336"/>
+            <a:ext cx="3035808" cy="530352"/>
+          </a:xfrm>
+          <a:prstGeom prst="rect">
+            <a:avLst/>
+          </a:prstGeom>
+          <a:noFill/>
+          <a:ln/>
+        </p:spPr>
+        <p:txBody>
+          <a:bodyPr wrap="square" lIns="254" tIns="254" rIns="254" bIns="254" rtlCol="0" anchor="t">
+            <a:normAutofit/>
+          </a:bodyPr>
+          <a:lstStyle/>
+          <a:p>
+            <a:pPr indent="0" marL="0">
+              <a:buNone/>
+            </a:pPr>
+            <a:r>
+              <a:rPr lang="en-US" sz="1130" dirty="0">
+                <a:solidFill>
+                  <a:srgbClr val="60746F"/>
+                </a:solidFill>
+              </a:rPr>
+              <a:t>T0 + 2–6 недель</a:t>
+            </a:r>
+            <a:endParaRPr lang="en-US" sz="1130" dirty="0"/>
+          </a:p>
+          <a:p>
+            <a:pPr indent="0" marL="0">
+              <a:buNone/>
+            </a:pPr>
+            <a:r>
+              <a:rPr lang="en-US" sz="1130" dirty="0">
+                <a:solidFill>
+                  <a:srgbClr val="60746F"/>
+                </a:solidFill>
+              </a:rPr>
+              <a:t>процессы и данные</a:t>
+            </a:r>
+            <a:endParaRPr lang="en-US" sz="1130" dirty="0"/>
+          </a:p>
+        </p:txBody>
+      </p:sp>
+      <p:sp>
+        <p:nvSpPr>
+          <p:cNvPr id="18" name="Shape 16"/>
+          <p:cNvSpPr/>
+          <p:nvPr/>
+        </p:nvSpPr>
+        <p:spPr>
+          <a:xfrm>
+            <a:off x="658368" y="3858768"/>
+            <a:ext cx="3419856" cy="1298448"/>
+          </a:xfrm>
+          <a:prstGeom prst="roundRect">
+            <a:avLst>
+              <a:gd name="adj" fmla="val 5634"/>
+            </a:avLst>
+          </a:prstGeom>
+          <a:solidFill>
+            <a:srgbClr val="FFFFFF"/>
+          </a:solidFill>
+          <a:ln w="8890">
             <a:solidFill>
-              <a:srgbClr val="BDE3D7"/>
+              <a:srgbClr val="D7E1DE"/>
             </a:solidFill>
             <a:prstDash val="solid"/>
           </a:ln>
-        </p:spPr>
-      </p:sp>
-      <p:sp>
-        <p:nvSpPr>
-          <p:cNvPr id="21" name="Text 19"/>
-          <p:cNvSpPr/>
-          <p:nvPr/>
-        </p:nvSpPr>
-        <p:spPr>
-          <a:xfrm>
-            <a:off x="4105656" y="3401568"/>
-            <a:ext cx="1024128" cy="256032"/>
-          </a:xfrm>
-          <a:prstGeom prst="rect">
-            <a:avLst/>
-          </a:prstGeom>
-          <a:noFill/>
-          <a:ln/>
-        </p:spPr>
-        <p:txBody>
-          <a:bodyPr wrap="square" lIns="0" tIns="0" rIns="0" bIns="0" rtlCol="0" anchor="ctr">
-            <a:normAutofit/>
-          </a:bodyPr>
-          <a:lstStyle/>
-          <a:p>
-            <a:pPr algn="ctr" indent="0" marL="0">
-              <a:buNone/>
-            </a:pPr>
-            <a:r>
-              <a:rPr lang="en-US" sz="1150" b="1" dirty="0">
-                <a:solidFill>
-                  <a:srgbClr val="18302C"/>
-                </a:solidFill>
-              </a:rPr>
-              <a:t>Обследование</a:t>
-            </a:r>
-            <a:endParaRPr lang="en-US" sz="1150" dirty="0"/>
-          </a:p>
-        </p:txBody>
-      </p:sp>
-      <p:sp>
-        <p:nvSpPr>
-          <p:cNvPr id="22" name="Text 20"/>
-          <p:cNvSpPr/>
-          <p:nvPr/>
-        </p:nvSpPr>
-        <p:spPr>
-          <a:xfrm>
-            <a:off x="4014216" y="3794760"/>
-            <a:ext cx="1207008" cy="210312"/>
-          </a:xfrm>
-          <a:prstGeom prst="rect">
-            <a:avLst/>
-          </a:prstGeom>
-          <a:noFill/>
-          <a:ln/>
-        </p:spPr>
-        <p:txBody>
-          <a:bodyPr wrap="square" lIns="0" tIns="0" rIns="0" bIns="0" rtlCol="0" anchor="ctr">
-            <a:normAutofit/>
-          </a:bodyPr>
-          <a:lstStyle/>
-          <a:p>
-            <a:pPr algn="ctr" indent="0" marL="0">
-              <a:buNone/>
-            </a:pPr>
-            <a:r>
-              <a:rPr lang="en-US" sz="950" b="1" dirty="0">
-                <a:solidFill>
-                  <a:srgbClr val="2F8B7B"/>
-                </a:solidFill>
-              </a:rPr>
-              <a:t>T0 + 2–6</a:t>
-            </a:r>
-            <a:endParaRPr lang="en-US" sz="950" dirty="0"/>
-          </a:p>
-        </p:txBody>
-      </p:sp>
-      <p:sp>
-        <p:nvSpPr>
-          <p:cNvPr id="23" name="Text 21"/>
-          <p:cNvSpPr/>
-          <p:nvPr/>
-        </p:nvSpPr>
-        <p:spPr>
-          <a:xfrm>
-            <a:off x="3986784" y="4151376"/>
-            <a:ext cx="1261872" cy="347472"/>
-          </a:xfrm>
-          <a:prstGeom prst="rect">
-            <a:avLst/>
-          </a:prstGeom>
-          <a:noFill/>
-          <a:ln/>
-        </p:spPr>
-        <p:txBody>
-          <a:bodyPr wrap="square" lIns="0" tIns="0" rIns="0" bIns="0" rtlCol="0" anchor="ctr">
-            <a:normAutofit/>
-          </a:bodyPr>
-          <a:lstStyle/>
-          <a:p>
-            <a:pPr algn="ctr" indent="0" marL="0">
-              <a:buNone/>
-            </a:pPr>
-            <a:r>
-              <a:rPr lang="en-US" sz="920" dirty="0">
-                <a:solidFill>
-                  <a:srgbClr val="60746F"/>
-                </a:solidFill>
-              </a:rPr>
-              <a:t>процессы и данные</a:t>
-            </a:r>
-            <a:endParaRPr lang="en-US" sz="920" dirty="0"/>
-          </a:p>
-        </p:txBody>
-      </p:sp>
-      <p:sp>
-        <p:nvSpPr>
-          <p:cNvPr id="24" name="Shape 22"/>
-          <p:cNvSpPr/>
-          <p:nvPr/>
-        </p:nvSpPr>
-        <p:spPr>
-          <a:xfrm>
-            <a:off x="6190488" y="2423160"/>
-            <a:ext cx="694944" cy="694944"/>
-          </a:xfrm>
-          <a:prstGeom prst="ellipse">
+          <a:effectLst>
+            <a:outerShdw sx="100000" sy="100000" kx="0" ky="0" algn="bl" rotWithShape="0" blurRad="25400" dist="50800" dir="2700000">
+              <a:srgbClr val="6B827B">
+                <a:alpha val="10000"/>
+              </a:srgbClr>
+            </a:outerShdw>
+          </a:effectLst>
+        </p:spPr>
+      </p:sp>
+      <p:sp>
+        <p:nvSpPr>
+          <p:cNvPr id="19" name="Shape 17"/>
+          <p:cNvSpPr/>
+          <p:nvPr/>
+        </p:nvSpPr>
+        <p:spPr>
+          <a:xfrm>
+            <a:off x="658368" y="3858768"/>
+            <a:ext cx="91440" cy="1298448"/>
+          </a:xfrm>
+          <a:prstGeom prst="rect">
             <a:avLst/>
           </a:prstGeom>
           <a:solidFill>
@@ -6077,189 +5978,140 @@
       </p:sp>
       <p:sp>
         <p:nvSpPr>
-          <p:cNvPr id="25" name="Text 23"/>
-          <p:cNvSpPr/>
-          <p:nvPr/>
-        </p:nvSpPr>
-        <p:spPr>
-          <a:xfrm>
-            <a:off x="6190488" y="2633472"/>
-            <a:ext cx="694944" cy="164592"/>
-          </a:xfrm>
-          <a:prstGeom prst="rect">
-            <a:avLst/>
-          </a:prstGeom>
-          <a:noFill/>
-          <a:ln/>
-        </p:spPr>
-        <p:txBody>
-          <a:bodyPr wrap="square" lIns="0" tIns="0" rIns="0" bIns="0" rtlCol="0" anchor="ctr"/>
-          <a:lstStyle/>
-          <a:p>
-            <a:pPr algn="ctr" indent="0" marL="0">
-              <a:buNone/>
-            </a:pPr>
-            <a:r>
-              <a:rPr lang="en-US" sz="1000" b="1" dirty="0">
-                <a:solidFill>
-                  <a:srgbClr val="FFFFFF"/>
-                </a:solidFill>
-              </a:rPr>
-              <a:t>3</a:t>
-            </a:r>
-            <a:endParaRPr lang="en-US" sz="1000" dirty="0"/>
-          </a:p>
-        </p:txBody>
-      </p:sp>
-      <p:sp>
-        <p:nvSpPr>
-          <p:cNvPr id="26" name="Shape 24"/>
-          <p:cNvSpPr/>
-          <p:nvPr/>
-        </p:nvSpPr>
-        <p:spPr>
-          <a:xfrm>
-            <a:off x="6903720" y="2761488"/>
-            <a:ext cx="1078992" cy="0"/>
-          </a:xfrm>
-          <a:prstGeom prst="line">
-            <a:avLst/>
-          </a:prstGeom>
-          <a:noFill/>
-          <a:ln w="25400">
+          <p:cNvPr id="20" name="Text 18"/>
+          <p:cNvSpPr/>
+          <p:nvPr/>
+        </p:nvSpPr>
+        <p:spPr>
+          <a:xfrm>
+            <a:off x="886968" y="4032504"/>
+            <a:ext cx="3035808" cy="310896"/>
+          </a:xfrm>
+          <a:prstGeom prst="rect">
+            <a:avLst/>
+          </a:prstGeom>
+          <a:noFill/>
+          <a:ln/>
+        </p:spPr>
+        <p:txBody>
+          <a:bodyPr wrap="square" lIns="0" tIns="0" rIns="0" bIns="0" rtlCol="0" anchor="ctr">
+            <a:normAutofit/>
+          </a:bodyPr>
+          <a:lstStyle/>
+          <a:p>
+            <a:pPr indent="0" marL="0">
+              <a:buNone/>
+            </a:pPr>
+            <a:r>
+              <a:rPr lang="en-US" sz="1400" b="1" dirty="0">
+                <a:solidFill>
+                  <a:srgbClr val="18302C"/>
+                </a:solidFill>
+              </a:rPr>
+              <a:t>3 · Выбор пилотов</a:t>
+            </a:r>
+            <a:endParaRPr lang="en-US" sz="1400" dirty="0"/>
+          </a:p>
+        </p:txBody>
+      </p:sp>
+      <p:sp>
+        <p:nvSpPr>
+          <p:cNvPr id="21" name="Text 19"/>
+          <p:cNvSpPr/>
+          <p:nvPr/>
+        </p:nvSpPr>
+        <p:spPr>
+          <a:xfrm>
+            <a:off x="886968" y="4462272"/>
+            <a:ext cx="3035808" cy="530352"/>
+          </a:xfrm>
+          <a:prstGeom prst="rect">
+            <a:avLst/>
+          </a:prstGeom>
+          <a:noFill/>
+          <a:ln/>
+        </p:spPr>
+        <p:txBody>
+          <a:bodyPr wrap="square" lIns="254" tIns="254" rIns="254" bIns="254" rtlCol="0" anchor="t">
+            <a:normAutofit/>
+          </a:bodyPr>
+          <a:lstStyle/>
+          <a:p>
+            <a:pPr indent="0" marL="0">
+              <a:buNone/>
+            </a:pPr>
+            <a:r>
+              <a:rPr lang="en-US" sz="1130" dirty="0">
+                <a:solidFill>
+                  <a:srgbClr val="60746F"/>
+                </a:solidFill>
+              </a:rPr>
+              <a:t>T0 + 5–8 недель</a:t>
+            </a:r>
+            <a:endParaRPr lang="en-US" sz="1130" dirty="0"/>
+          </a:p>
+          <a:p>
+            <a:pPr indent="0" marL="0">
+              <a:buNone/>
+            </a:pPr>
+            <a:r>
+              <a:rPr lang="en-US" sz="1130" dirty="0">
+                <a:solidFill>
+                  <a:srgbClr val="60746F"/>
+                </a:solidFill>
+              </a:rPr>
+              <a:t>приоритеты и допуск</a:t>
+            </a:r>
+            <a:endParaRPr lang="en-US" sz="1130" dirty="0"/>
+          </a:p>
+        </p:txBody>
+      </p:sp>
+      <p:sp>
+        <p:nvSpPr>
+          <p:cNvPr id="22" name="Shape 20"/>
+          <p:cNvSpPr/>
+          <p:nvPr/>
+        </p:nvSpPr>
+        <p:spPr>
+          <a:xfrm>
+            <a:off x="4370832" y="3858768"/>
+            <a:ext cx="3419856" cy="1298448"/>
+          </a:xfrm>
+          <a:prstGeom prst="roundRect">
+            <a:avLst>
+              <a:gd name="adj" fmla="val 5634"/>
+            </a:avLst>
+          </a:prstGeom>
+          <a:solidFill>
+            <a:srgbClr val="FFFFFF"/>
+          </a:solidFill>
+          <a:ln w="8890">
             <a:solidFill>
-              <a:srgbClr val="BDE3D7"/>
+              <a:srgbClr val="D7E1DE"/>
             </a:solidFill>
             <a:prstDash val="solid"/>
           </a:ln>
-        </p:spPr>
-      </p:sp>
-      <p:sp>
-        <p:nvSpPr>
-          <p:cNvPr id="27" name="Text 25"/>
-          <p:cNvSpPr/>
-          <p:nvPr/>
-        </p:nvSpPr>
-        <p:spPr>
-          <a:xfrm>
-            <a:off x="6035040" y="3401568"/>
-            <a:ext cx="1024128" cy="256032"/>
-          </a:xfrm>
-          <a:prstGeom prst="rect">
-            <a:avLst/>
-          </a:prstGeom>
-          <a:noFill/>
-          <a:ln/>
-        </p:spPr>
-        <p:txBody>
-          <a:bodyPr wrap="square" lIns="0" tIns="0" rIns="0" bIns="0" rtlCol="0" anchor="ctr">
-            <a:normAutofit/>
-          </a:bodyPr>
-          <a:lstStyle/>
-          <a:p>
-            <a:pPr algn="ctr" indent="0" marL="0">
-              <a:buNone/>
-            </a:pPr>
-            <a:r>
-              <a:rPr lang="en-US" sz="1150" b="1" dirty="0">
-                <a:solidFill>
-                  <a:srgbClr val="18302C"/>
-                </a:solidFill>
-              </a:rPr>
-              <a:t>Пилоты</a:t>
-            </a:r>
-            <a:endParaRPr lang="en-US" sz="1150" dirty="0"/>
-          </a:p>
-        </p:txBody>
-      </p:sp>
-      <p:sp>
-        <p:nvSpPr>
-          <p:cNvPr id="28" name="Text 26"/>
-          <p:cNvSpPr/>
-          <p:nvPr/>
-        </p:nvSpPr>
-        <p:spPr>
-          <a:xfrm>
-            <a:off x="5943600" y="3794760"/>
-            <a:ext cx="1207008" cy="210312"/>
-          </a:xfrm>
-          <a:prstGeom prst="rect">
-            <a:avLst/>
-          </a:prstGeom>
-          <a:noFill/>
-          <a:ln/>
-        </p:spPr>
-        <p:txBody>
-          <a:bodyPr wrap="square" lIns="0" tIns="0" rIns="0" bIns="0" rtlCol="0" anchor="ctr">
-            <a:normAutofit/>
-          </a:bodyPr>
-          <a:lstStyle/>
-          <a:p>
-            <a:pPr algn="ctr" indent="0" marL="0">
-              <a:buNone/>
-            </a:pPr>
-            <a:r>
-              <a:rPr lang="en-US" sz="950" b="1" dirty="0">
-                <a:solidFill>
-                  <a:srgbClr val="2F8B7B"/>
-                </a:solidFill>
-              </a:rPr>
-              <a:t>T0 + 5–8</a:t>
-            </a:r>
-            <a:endParaRPr lang="en-US" sz="950" dirty="0"/>
-          </a:p>
-        </p:txBody>
-      </p:sp>
-      <p:sp>
-        <p:nvSpPr>
-          <p:cNvPr id="29" name="Text 27"/>
-          <p:cNvSpPr/>
-          <p:nvPr/>
-        </p:nvSpPr>
-        <p:spPr>
-          <a:xfrm>
-            <a:off x="5916168" y="4151376"/>
-            <a:ext cx="1261872" cy="347472"/>
-          </a:xfrm>
-          <a:prstGeom prst="rect">
-            <a:avLst/>
-          </a:prstGeom>
-          <a:noFill/>
-          <a:ln/>
-        </p:spPr>
-        <p:txBody>
-          <a:bodyPr wrap="square" lIns="0" tIns="0" rIns="0" bIns="0" rtlCol="0" anchor="ctr">
-            <a:normAutofit/>
-          </a:bodyPr>
-          <a:lstStyle/>
-          <a:p>
-            <a:pPr algn="ctr" indent="0" marL="0">
-              <a:buNone/>
-            </a:pPr>
-            <a:r>
-              <a:rPr lang="en-US" sz="920" dirty="0">
-                <a:solidFill>
-                  <a:srgbClr val="60746F"/>
-                </a:solidFill>
-              </a:rPr>
-              <a:t>выбор и допуск</a:t>
-            </a:r>
-            <a:endParaRPr lang="en-US" sz="920" dirty="0"/>
-          </a:p>
-        </p:txBody>
-      </p:sp>
-      <p:sp>
-        <p:nvSpPr>
-          <p:cNvPr id="30" name="Shape 28"/>
-          <p:cNvSpPr/>
-          <p:nvPr/>
-        </p:nvSpPr>
-        <p:spPr>
-          <a:xfrm>
-            <a:off x="8119872" y="2423160"/>
-            <a:ext cx="694944" cy="694944"/>
-          </a:xfrm>
-          <a:prstGeom prst="ellipse">
+          <a:effectLst>
+            <a:outerShdw sx="100000" sy="100000" kx="0" ky="0" algn="bl" rotWithShape="0" blurRad="25400" dist="50800" dir="2700000">
+              <a:srgbClr val="6B827B">
+                <a:alpha val="10000"/>
+              </a:srgbClr>
+            </a:outerShdw>
+          </a:effectLst>
+        </p:spPr>
+      </p:sp>
+      <p:sp>
+        <p:nvSpPr>
+          <p:cNvPr id="23" name="Shape 21"/>
+          <p:cNvSpPr/>
+          <p:nvPr/>
+        </p:nvSpPr>
+        <p:spPr>
+          <a:xfrm>
+            <a:off x="4370832" y="3858768"/>
+            <a:ext cx="91440" cy="1298448"/>
+          </a:xfrm>
+          <a:prstGeom prst="rect">
             <a:avLst/>
           </a:prstGeom>
           <a:solidFill>
@@ -6275,189 +6127,140 @@
       </p:sp>
       <p:sp>
         <p:nvSpPr>
-          <p:cNvPr id="31" name="Text 29"/>
-          <p:cNvSpPr/>
-          <p:nvPr/>
-        </p:nvSpPr>
-        <p:spPr>
-          <a:xfrm>
-            <a:off x="8119872" y="2633472"/>
-            <a:ext cx="694944" cy="164592"/>
-          </a:xfrm>
-          <a:prstGeom prst="rect">
-            <a:avLst/>
-          </a:prstGeom>
-          <a:noFill/>
-          <a:ln/>
-        </p:spPr>
-        <p:txBody>
-          <a:bodyPr wrap="square" lIns="0" tIns="0" rIns="0" bIns="0" rtlCol="0" anchor="ctr"/>
-          <a:lstStyle/>
-          <a:p>
-            <a:pPr algn="ctr" indent="0" marL="0">
-              <a:buNone/>
-            </a:pPr>
-            <a:r>
-              <a:rPr lang="en-US" sz="1000" b="1" dirty="0">
-                <a:solidFill>
-                  <a:srgbClr val="FFFFFF"/>
-                </a:solidFill>
-              </a:rPr>
-              <a:t>4</a:t>
-            </a:r>
-            <a:endParaRPr lang="en-US" sz="1000" dirty="0"/>
-          </a:p>
-        </p:txBody>
-      </p:sp>
-      <p:sp>
-        <p:nvSpPr>
-          <p:cNvPr id="32" name="Shape 30"/>
-          <p:cNvSpPr/>
-          <p:nvPr/>
-        </p:nvSpPr>
-        <p:spPr>
-          <a:xfrm>
-            <a:off x="8833104" y="2761488"/>
-            <a:ext cx="1078992" cy="0"/>
-          </a:xfrm>
-          <a:prstGeom prst="line">
-            <a:avLst/>
-          </a:prstGeom>
-          <a:noFill/>
-          <a:ln w="25400">
+          <p:cNvPr id="24" name="Text 22"/>
+          <p:cNvSpPr/>
+          <p:nvPr/>
+        </p:nvSpPr>
+        <p:spPr>
+          <a:xfrm>
+            <a:off x="4599432" y="4032504"/>
+            <a:ext cx="3035808" cy="310896"/>
+          </a:xfrm>
+          <a:prstGeom prst="rect">
+            <a:avLst/>
+          </a:prstGeom>
+          <a:noFill/>
+          <a:ln/>
+        </p:spPr>
+        <p:txBody>
+          <a:bodyPr wrap="square" lIns="0" tIns="0" rIns="0" bIns="0" rtlCol="0" anchor="ctr">
+            <a:normAutofit/>
+          </a:bodyPr>
+          <a:lstStyle/>
+          <a:p>
+            <a:pPr indent="0" marL="0">
+              <a:buNone/>
+            </a:pPr>
+            <a:r>
+              <a:rPr lang="en-US" sz="1400" b="1" dirty="0">
+                <a:solidFill>
+                  <a:srgbClr val="18302C"/>
+                </a:solidFill>
+              </a:rPr>
+              <a:t>4 · Запуск MVP</a:t>
+            </a:r>
+            <a:endParaRPr lang="en-US" sz="1400" dirty="0"/>
+          </a:p>
+        </p:txBody>
+      </p:sp>
+      <p:sp>
+        <p:nvSpPr>
+          <p:cNvPr id="25" name="Text 23"/>
+          <p:cNvSpPr/>
+          <p:nvPr/>
+        </p:nvSpPr>
+        <p:spPr>
+          <a:xfrm>
+            <a:off x="4599432" y="4462272"/>
+            <a:ext cx="3035808" cy="530352"/>
+          </a:xfrm>
+          <a:prstGeom prst="rect">
+            <a:avLst/>
+          </a:prstGeom>
+          <a:noFill/>
+          <a:ln/>
+        </p:spPr>
+        <p:txBody>
+          <a:bodyPr wrap="square" lIns="254" tIns="254" rIns="254" bIns="254" rtlCol="0" anchor="t">
+            <a:normAutofit/>
+          </a:bodyPr>
+          <a:lstStyle/>
+          <a:p>
+            <a:pPr indent="0" marL="0">
+              <a:buNone/>
+            </a:pPr>
+            <a:r>
+              <a:rPr lang="en-US" sz="1130" dirty="0">
+                <a:solidFill>
+                  <a:srgbClr val="60746F"/>
+                </a:solidFill>
+              </a:rPr>
+              <a:t>T0 + 7–14 недель</a:t>
+            </a:r>
+            <a:endParaRPr lang="en-US" sz="1130" dirty="0"/>
+          </a:p>
+          <a:p>
+            <a:pPr indent="0" marL="0">
+              <a:buNone/>
+            </a:pPr>
+            <a:r>
+              <a:rPr lang="en-US" sz="1130" dirty="0">
+                <a:solidFill>
+                  <a:srgbClr val="60746F"/>
+                </a:solidFill>
+              </a:rPr>
+              <a:t>MVP и метрики</a:t>
+            </a:r>
+            <a:endParaRPr lang="en-US" sz="1130" dirty="0"/>
+          </a:p>
+        </p:txBody>
+      </p:sp>
+      <p:sp>
+        <p:nvSpPr>
+          <p:cNvPr id="26" name="Shape 24"/>
+          <p:cNvSpPr/>
+          <p:nvPr/>
+        </p:nvSpPr>
+        <p:spPr>
+          <a:xfrm>
+            <a:off x="8083296" y="3858768"/>
+            <a:ext cx="3419856" cy="1298448"/>
+          </a:xfrm>
+          <a:prstGeom prst="roundRect">
+            <a:avLst>
+              <a:gd name="adj" fmla="val 5634"/>
+            </a:avLst>
+          </a:prstGeom>
+          <a:solidFill>
+            <a:srgbClr val="FFFFFF"/>
+          </a:solidFill>
+          <a:ln w="8890">
             <a:solidFill>
-              <a:srgbClr val="BDE3D7"/>
+              <a:srgbClr val="D7E1DE"/>
             </a:solidFill>
             <a:prstDash val="solid"/>
           </a:ln>
-        </p:spPr>
-      </p:sp>
-      <p:sp>
-        <p:nvSpPr>
-          <p:cNvPr id="33" name="Text 31"/>
-          <p:cNvSpPr/>
-          <p:nvPr/>
-        </p:nvSpPr>
-        <p:spPr>
-          <a:xfrm>
-            <a:off x="7964424" y="3401568"/>
-            <a:ext cx="1024128" cy="256032"/>
-          </a:xfrm>
-          <a:prstGeom prst="rect">
-            <a:avLst/>
-          </a:prstGeom>
-          <a:noFill/>
-          <a:ln/>
-        </p:spPr>
-        <p:txBody>
-          <a:bodyPr wrap="square" lIns="0" tIns="0" rIns="0" bIns="0" rtlCol="0" anchor="ctr">
-            <a:normAutofit/>
-          </a:bodyPr>
-          <a:lstStyle/>
-          <a:p>
-            <a:pPr algn="ctr" indent="0" marL="0">
-              <a:buNone/>
-            </a:pPr>
-            <a:r>
-              <a:rPr lang="en-US" sz="1150" b="1" dirty="0">
-                <a:solidFill>
-                  <a:srgbClr val="18302C"/>
-                </a:solidFill>
-              </a:rPr>
-              <a:t>Запуск</a:t>
-            </a:r>
-            <a:endParaRPr lang="en-US" sz="1150" dirty="0"/>
-          </a:p>
-        </p:txBody>
-      </p:sp>
-      <p:sp>
-        <p:nvSpPr>
-          <p:cNvPr id="34" name="Text 32"/>
-          <p:cNvSpPr/>
-          <p:nvPr/>
-        </p:nvSpPr>
-        <p:spPr>
-          <a:xfrm>
-            <a:off x="7872984" y="3794760"/>
-            <a:ext cx="1207008" cy="210312"/>
-          </a:xfrm>
-          <a:prstGeom prst="rect">
-            <a:avLst/>
-          </a:prstGeom>
-          <a:noFill/>
-          <a:ln/>
-        </p:spPr>
-        <p:txBody>
-          <a:bodyPr wrap="square" lIns="0" tIns="0" rIns="0" bIns="0" rtlCol="0" anchor="ctr">
-            <a:normAutofit/>
-          </a:bodyPr>
-          <a:lstStyle/>
-          <a:p>
-            <a:pPr algn="ctr" indent="0" marL="0">
-              <a:buNone/>
-            </a:pPr>
-            <a:r>
-              <a:rPr lang="en-US" sz="950" b="1" dirty="0">
-                <a:solidFill>
-                  <a:srgbClr val="2F8B7B"/>
-                </a:solidFill>
-              </a:rPr>
-              <a:t>T0 + 7–14</a:t>
-            </a:r>
-            <a:endParaRPr lang="en-US" sz="950" dirty="0"/>
-          </a:p>
-        </p:txBody>
-      </p:sp>
-      <p:sp>
-        <p:nvSpPr>
-          <p:cNvPr id="35" name="Text 33"/>
-          <p:cNvSpPr/>
-          <p:nvPr/>
-        </p:nvSpPr>
-        <p:spPr>
-          <a:xfrm>
-            <a:off x="7845552" y="4151376"/>
-            <a:ext cx="1261872" cy="347472"/>
-          </a:xfrm>
-          <a:prstGeom prst="rect">
-            <a:avLst/>
-          </a:prstGeom>
-          <a:noFill/>
-          <a:ln/>
-        </p:spPr>
-        <p:txBody>
-          <a:bodyPr wrap="square" lIns="0" tIns="0" rIns="0" bIns="0" rtlCol="0" anchor="ctr">
-            <a:normAutofit/>
-          </a:bodyPr>
-          <a:lstStyle/>
-          <a:p>
-            <a:pPr algn="ctr" indent="0" marL="0">
-              <a:buNone/>
-            </a:pPr>
-            <a:r>
-              <a:rPr lang="en-US" sz="920" dirty="0">
-                <a:solidFill>
-                  <a:srgbClr val="60746F"/>
-                </a:solidFill>
-              </a:rPr>
-              <a:t>MVP и метрики</a:t>
-            </a:r>
-            <a:endParaRPr lang="en-US" sz="920" dirty="0"/>
-          </a:p>
-        </p:txBody>
-      </p:sp>
-      <p:sp>
-        <p:nvSpPr>
-          <p:cNvPr id="36" name="Shape 34"/>
-          <p:cNvSpPr/>
-          <p:nvPr/>
-        </p:nvSpPr>
-        <p:spPr>
-          <a:xfrm>
-            <a:off x="10049256" y="2423160"/>
-            <a:ext cx="694944" cy="694944"/>
-          </a:xfrm>
-          <a:prstGeom prst="ellipse">
+          <a:effectLst>
+            <a:outerShdw sx="100000" sy="100000" kx="0" ky="0" algn="bl" rotWithShape="0" blurRad="25400" dist="50800" dir="2700000">
+              <a:srgbClr val="6B827B">
+                <a:alpha val="10000"/>
+              </a:srgbClr>
+            </a:outerShdw>
+          </a:effectLst>
+        </p:spPr>
+      </p:sp>
+      <p:sp>
+        <p:nvSpPr>
+          <p:cNvPr id="27" name="Shape 25"/>
+          <p:cNvSpPr/>
+          <p:nvPr/>
+        </p:nvSpPr>
+        <p:spPr>
+          <a:xfrm>
+            <a:off x="8083296" y="3858768"/>
+            <a:ext cx="91440" cy="1298448"/>
+          </a:xfrm>
+          <a:prstGeom prst="rect">
             <a:avLst/>
           </a:prstGeom>
           <a:solidFill>
@@ -6473,50 +6276,14 @@
       </p:sp>
       <p:sp>
         <p:nvSpPr>
-          <p:cNvPr id="37" name="Text 35"/>
-          <p:cNvSpPr/>
-          <p:nvPr/>
-        </p:nvSpPr>
-        <p:spPr>
-          <a:xfrm>
-            <a:off x="10049256" y="2633472"/>
-            <a:ext cx="694944" cy="164592"/>
-          </a:xfrm>
-          <a:prstGeom prst="rect">
-            <a:avLst/>
-          </a:prstGeom>
-          <a:noFill/>
-          <a:ln/>
-        </p:spPr>
-        <p:txBody>
-          <a:bodyPr wrap="square" lIns="0" tIns="0" rIns="0" bIns="0" rtlCol="0" anchor="ctr"/>
-          <a:lstStyle/>
-          <a:p>
-            <a:pPr algn="ctr" indent="0" marL="0">
-              <a:buNone/>
-            </a:pPr>
-            <a:r>
-              <a:rPr lang="en-US" sz="1000" b="1" dirty="0">
-                <a:solidFill>
-                  <a:srgbClr val="FFFFFF"/>
-                </a:solidFill>
-              </a:rPr>
-              <a:t>G4</a:t>
-            </a:r>
-            <a:endParaRPr lang="en-US" sz="1000" dirty="0"/>
-          </a:p>
-        </p:txBody>
-      </p:sp>
-      <p:sp>
-        <p:nvSpPr>
-          <p:cNvPr id="38" name="Text 36"/>
-          <p:cNvSpPr/>
-          <p:nvPr/>
-        </p:nvSpPr>
-        <p:spPr>
-          <a:xfrm>
-            <a:off x="9893808" y="3401568"/>
-            <a:ext cx="1024128" cy="256032"/>
+          <p:cNvPr id="28" name="Text 26"/>
+          <p:cNvSpPr/>
+          <p:nvPr/>
+        </p:nvSpPr>
+        <p:spPr>
+          <a:xfrm>
+            <a:off x="8311896" y="4032504"/>
+            <a:ext cx="3035808" cy="310896"/>
           </a:xfrm>
           <a:prstGeom prst="rect">
             <a:avLst/>
@@ -6530,134 +6297,83 @@
           </a:bodyPr>
           <a:lstStyle/>
           <a:p>
-            <a:pPr algn="ctr" indent="0" marL="0">
-              <a:buNone/>
-            </a:pPr>
-            <a:r>
-              <a:rPr lang="en-US" sz="1150" b="1" dirty="0">
+            <a:pPr indent="0" marL="0">
+              <a:buNone/>
+            </a:pPr>
+            <a:r>
+              <a:rPr lang="en-US" sz="1400" b="1" dirty="0">
                 <a:solidFill>
                   <a:srgbClr val="18302C"/>
                 </a:solidFill>
               </a:rPr>
-              <a:t>Решение</a:t>
-            </a:r>
-            <a:endParaRPr lang="en-US" sz="1150" dirty="0"/>
-          </a:p>
-        </p:txBody>
-      </p:sp>
-      <p:sp>
-        <p:nvSpPr>
-          <p:cNvPr id="39" name="Text 37"/>
-          <p:cNvSpPr/>
-          <p:nvPr/>
-        </p:nvSpPr>
-        <p:spPr>
-          <a:xfrm>
-            <a:off x="9802368" y="3794760"/>
-            <a:ext cx="1207008" cy="210312"/>
-          </a:xfrm>
-          <a:prstGeom prst="rect">
-            <a:avLst/>
-          </a:prstGeom>
-          <a:noFill/>
-          <a:ln/>
-        </p:spPr>
-        <p:txBody>
-          <a:bodyPr wrap="square" lIns="0" tIns="0" rIns="0" bIns="0" rtlCol="0" anchor="ctr">
+              <a:t>G4 · Решение</a:t>
+            </a:r>
+            <a:endParaRPr lang="en-US" sz="1400" dirty="0"/>
+          </a:p>
+        </p:txBody>
+      </p:sp>
+      <p:sp>
+        <p:nvSpPr>
+          <p:cNvPr id="29" name="Text 27"/>
+          <p:cNvSpPr/>
+          <p:nvPr/>
+        </p:nvSpPr>
+        <p:spPr>
+          <a:xfrm>
+            <a:off x="8311896" y="4462272"/>
+            <a:ext cx="3035808" cy="530352"/>
+          </a:xfrm>
+          <a:prstGeom prst="rect">
+            <a:avLst/>
+          </a:prstGeom>
+          <a:noFill/>
+          <a:ln/>
+        </p:spPr>
+        <p:txBody>
+          <a:bodyPr wrap="square" lIns="254" tIns="254" rIns="254" bIns="254" rtlCol="0" anchor="t">
             <a:normAutofit/>
           </a:bodyPr>
           <a:lstStyle/>
           <a:p>
-            <a:pPr algn="ctr" indent="0" marL="0">
-              <a:buNone/>
-            </a:pPr>
-            <a:r>
-              <a:rPr lang="en-US" sz="950" b="1" dirty="0">
-                <a:solidFill>
-                  <a:srgbClr val="2F8B7B"/>
-                </a:solidFill>
-              </a:rPr>
-              <a:t>T0 + 13–16</a:t>
-            </a:r>
-            <a:endParaRPr lang="en-US" sz="950" dirty="0"/>
-          </a:p>
-        </p:txBody>
-      </p:sp>
-      <p:sp>
-        <p:nvSpPr>
-          <p:cNvPr id="40" name="Text 38"/>
-          <p:cNvSpPr/>
-          <p:nvPr/>
-        </p:nvSpPr>
-        <p:spPr>
-          <a:xfrm>
-            <a:off x="9774936" y="4151376"/>
-            <a:ext cx="1261872" cy="347472"/>
-          </a:xfrm>
-          <a:prstGeom prst="rect">
-            <a:avLst/>
-          </a:prstGeom>
-          <a:noFill/>
-          <a:ln/>
-        </p:spPr>
-        <p:txBody>
-          <a:bodyPr wrap="square" lIns="0" tIns="0" rIns="0" bIns="0" rtlCol="0" anchor="ctr">
-            <a:normAutofit/>
-          </a:bodyPr>
-          <a:lstStyle/>
-          <a:p>
-            <a:pPr algn="ctr" indent="0" marL="0">
-              <a:buNone/>
-            </a:pPr>
-            <a:r>
-              <a:rPr lang="en-US" sz="920" dirty="0">
+            <a:pPr indent="0" marL="0">
+              <a:buNone/>
+            </a:pPr>
+            <a:r>
+              <a:rPr lang="en-US" sz="1130" dirty="0">
                 <a:solidFill>
                   <a:srgbClr val="60746F"/>
                 </a:solidFill>
               </a:rPr>
+              <a:t>T0 + 13–16 недель</a:t>
+            </a:r>
+            <a:endParaRPr lang="en-US" sz="1130" dirty="0"/>
+          </a:p>
+          <a:p>
+            <a:pPr indent="0" marL="0">
+              <a:buNone/>
+            </a:pPr>
+            <a:r>
+              <a:rPr lang="en-US" sz="1130" dirty="0">
+                <a:solidFill>
+                  <a:srgbClr val="60746F"/>
+                </a:solidFill>
+              </a:rPr>
               <a:t>масштаб / стоп</a:t>
             </a:r>
-            <a:endParaRPr lang="en-US" sz="920" dirty="0"/>
-          </a:p>
-        </p:txBody>
-      </p:sp>
-      <p:sp>
-        <p:nvSpPr>
-          <p:cNvPr id="41" name="Shape 39"/>
-          <p:cNvSpPr/>
-          <p:nvPr/>
-        </p:nvSpPr>
-        <p:spPr>
-          <a:xfrm>
-            <a:off x="658368" y="5193792"/>
-            <a:ext cx="10744200" cy="502920"/>
-          </a:xfrm>
-          <a:prstGeom prst="roundRect">
-            <a:avLst>
-              <a:gd name="adj" fmla="val 9091"/>
-            </a:avLst>
-          </a:prstGeom>
-          <a:solidFill>
-            <a:srgbClr val="E6F2EE"/>
-          </a:solidFill>
-          <a:ln w="12700">
-            <a:solidFill>
-              <a:srgbClr val="CBE1D9"/>
-            </a:solidFill>
-            <a:prstDash val="solid"/>
-          </a:ln>
-        </p:spPr>
-      </p:sp>
-      <p:sp>
-        <p:nvSpPr>
-          <p:cNvPr id="42" name="Text 40"/>
-          <p:cNvSpPr/>
-          <p:nvPr/>
-        </p:nvSpPr>
-        <p:spPr>
-          <a:xfrm>
-            <a:off x="896112" y="5358384"/>
-            <a:ext cx="10287000" cy="164592"/>
+            <a:endParaRPr lang="en-US" sz="1130" dirty="0"/>
+          </a:p>
+        </p:txBody>
+      </p:sp>
+      <p:sp>
+        <p:nvSpPr>
+          <p:cNvPr id="30" name="Text 28"/>
+          <p:cNvSpPr/>
+          <p:nvPr/>
+        </p:nvSpPr>
+        <p:spPr>
+          <a:xfrm>
+            <a:off x="777240" y="5650992"/>
+            <a:ext cx="10607040" cy="201168"/>
           </a:xfrm>
           <a:prstGeom prst="rect">
             <a:avLst/>
@@ -7828,8 +7544,35 @@
         </p:nvSpPr>
         <p:spPr>
           <a:xfrm>
-            <a:off x="822960" y="2331720"/>
-            <a:ext cx="530352" cy="530352"/>
+            <a:off x="713232" y="2212848"/>
+            <a:ext cx="3255264" cy="1335024"/>
+          </a:xfrm>
+          <a:prstGeom prst="roundRect">
+            <a:avLst>
+              <a:gd name="adj" fmla="val 4795"/>
+            </a:avLst>
+          </a:prstGeom>
+          <a:solidFill>
+            <a:srgbClr val="1E554D"/>
+          </a:solidFill>
+          <a:ln w="10160">
+            <a:solidFill>
+              <a:srgbClr val="3C786D"/>
+            </a:solidFill>
+            <a:prstDash val="solid"/>
+          </a:ln>
+        </p:spPr>
+      </p:sp>
+      <p:sp>
+        <p:nvSpPr>
+          <p:cNvPr id="7" name="Shape 5"/>
+          <p:cNvSpPr/>
+          <p:nvPr/>
+        </p:nvSpPr>
+        <p:spPr>
+          <a:xfrm>
+            <a:off x="896112" y="2414016"/>
+            <a:ext cx="438912" cy="438912"/>
           </a:xfrm>
           <a:prstGeom prst="ellipse">
             <a:avLst/>
@@ -7847,14 +7590,14 @@
       </p:sp>
       <p:sp>
         <p:nvSpPr>
-          <p:cNvPr id="7" name="Text 5"/>
-          <p:cNvSpPr/>
-          <p:nvPr/>
-        </p:nvSpPr>
-        <p:spPr>
-          <a:xfrm>
-            <a:off x="822960" y="2459736"/>
-            <a:ext cx="530352" cy="164592"/>
+          <p:cNvPr id="8" name="Text 6"/>
+          <p:cNvSpPr/>
+          <p:nvPr/>
+        </p:nvSpPr>
+        <p:spPr>
+          <a:xfrm>
+            <a:off x="896112" y="2532888"/>
+            <a:ext cx="438912" cy="128016"/>
           </a:xfrm>
           <a:prstGeom prst="rect">
             <a:avLst/>
@@ -7870,27 +7613,27 @@
               <a:buNone/>
             </a:pPr>
             <a:r>
-              <a:rPr lang="en-US" sz="1300" b="1" dirty="0">
+              <a:rPr lang="en-US" sz="1000" b="1" dirty="0">
                 <a:solidFill>
                   <a:srgbClr val="FFFFFF"/>
                 </a:solidFill>
               </a:rPr>
               <a:t>1</a:t>
             </a:r>
-            <a:endParaRPr lang="en-US" sz="1300" dirty="0"/>
-          </a:p>
-        </p:txBody>
-      </p:sp>
-      <p:sp>
-        <p:nvSpPr>
-          <p:cNvPr id="8" name="Text 6"/>
-          <p:cNvSpPr/>
-          <p:nvPr/>
-        </p:nvSpPr>
-        <p:spPr>
-          <a:xfrm>
-            <a:off x="1499616" y="2359152"/>
-            <a:ext cx="1417320" cy="201168"/>
+            <a:endParaRPr lang="en-US" sz="1000" dirty="0"/>
+          </a:p>
+        </p:txBody>
+      </p:sp>
+      <p:sp>
+        <p:nvSpPr>
+          <p:cNvPr id="9" name="Text 7"/>
+          <p:cNvSpPr/>
+          <p:nvPr/>
+        </p:nvSpPr>
+        <p:spPr>
+          <a:xfrm>
+            <a:off x="1481328" y="2414016"/>
+            <a:ext cx="2267712" cy="228600"/>
           </a:xfrm>
           <a:prstGeom prst="rect">
             <a:avLst/>
@@ -7908,27 +7651,27 @@
               <a:buNone/>
             </a:pPr>
             <a:r>
-              <a:rPr lang="en-US" sz="1200" b="1" dirty="0">
-                <a:solidFill>
-                  <a:srgbClr val="18302C"/>
+              <a:rPr lang="en-US" sz="1300" b="1" dirty="0">
+                <a:solidFill>
+                  <a:srgbClr val="FFFFFF"/>
                 </a:solidFill>
               </a:rPr>
               <a:t>Запуск первого этапа</a:t>
             </a:r>
-            <a:endParaRPr lang="en-US" sz="1200" dirty="0"/>
-          </a:p>
-        </p:txBody>
-      </p:sp>
-      <p:sp>
-        <p:nvSpPr>
-          <p:cNvPr id="9" name="Text 7"/>
-          <p:cNvSpPr/>
-          <p:nvPr/>
-        </p:nvSpPr>
-        <p:spPr>
-          <a:xfrm>
-            <a:off x="1499616" y="2606040"/>
-            <a:ext cx="1463040" cy="320040"/>
+            <a:endParaRPr lang="en-US" sz="1300" dirty="0"/>
+          </a:p>
+        </p:txBody>
+      </p:sp>
+      <p:sp>
+        <p:nvSpPr>
+          <p:cNvPr id="10" name="Text 8"/>
+          <p:cNvSpPr/>
+          <p:nvPr/>
+        </p:nvSpPr>
+        <p:spPr>
+          <a:xfrm>
+            <a:off x="896112" y="2944368"/>
+            <a:ext cx="2788920" cy="338328"/>
           </a:xfrm>
           <a:prstGeom prst="rect">
             <a:avLst/>
@@ -7946,27 +7689,54 @@
               <a:buNone/>
             </a:pPr>
             <a:r>
-              <a:rPr lang="en-US" sz="940" dirty="0">
-                <a:solidFill>
-                  <a:srgbClr val="60746F"/>
+              <a:rPr lang="en-US" sz="1120" dirty="0">
+                <a:solidFill>
+                  <a:srgbClr val="D9E7E2"/>
                 </a:solidFill>
               </a:rPr>
               <a:t>Обследование и подготовка пилотов после защиты паспорта</a:t>
             </a:r>
-            <a:endParaRPr lang="en-US" sz="940" dirty="0"/>
-          </a:p>
-        </p:txBody>
-      </p:sp>
-      <p:sp>
-        <p:nvSpPr>
-          <p:cNvPr id="10" name="Shape 8"/>
-          <p:cNvSpPr/>
-          <p:nvPr/>
-        </p:nvSpPr>
-        <p:spPr>
-          <a:xfrm>
-            <a:off x="822960" y="3127248"/>
-            <a:ext cx="530352" cy="530352"/>
+            <a:endParaRPr lang="en-US" sz="1120" dirty="0"/>
+          </a:p>
+        </p:txBody>
+      </p:sp>
+      <p:sp>
+        <p:nvSpPr>
+          <p:cNvPr id="11" name="Shape 9"/>
+          <p:cNvSpPr/>
+          <p:nvPr/>
+        </p:nvSpPr>
+        <p:spPr>
+          <a:xfrm>
+            <a:off x="4315968" y="2212848"/>
+            <a:ext cx="3255264" cy="1335024"/>
+          </a:xfrm>
+          <a:prstGeom prst="roundRect">
+            <a:avLst>
+              <a:gd name="adj" fmla="val 4795"/>
+            </a:avLst>
+          </a:prstGeom>
+          <a:solidFill>
+            <a:srgbClr val="1E554D"/>
+          </a:solidFill>
+          <a:ln w="10160">
+            <a:solidFill>
+              <a:srgbClr val="3C786D"/>
+            </a:solidFill>
+            <a:prstDash val="solid"/>
+          </a:ln>
+        </p:spPr>
+      </p:sp>
+      <p:sp>
+        <p:nvSpPr>
+          <p:cNvPr id="12" name="Shape 10"/>
+          <p:cNvSpPr/>
+          <p:nvPr/>
+        </p:nvSpPr>
+        <p:spPr>
+          <a:xfrm>
+            <a:off x="4498848" y="2414016"/>
+            <a:ext cx="438912" cy="438912"/>
           </a:xfrm>
           <a:prstGeom prst="ellipse">
             <a:avLst/>
@@ -7984,14 +7754,14 @@
       </p:sp>
       <p:sp>
         <p:nvSpPr>
-          <p:cNvPr id="11" name="Text 9"/>
-          <p:cNvSpPr/>
-          <p:nvPr/>
-        </p:nvSpPr>
-        <p:spPr>
-          <a:xfrm>
-            <a:off x="822960" y="3255264"/>
-            <a:ext cx="530352" cy="164592"/>
+          <p:cNvPr id="13" name="Text 11"/>
+          <p:cNvSpPr/>
+          <p:nvPr/>
+        </p:nvSpPr>
+        <p:spPr>
+          <a:xfrm>
+            <a:off x="4498848" y="2532888"/>
+            <a:ext cx="438912" cy="128016"/>
           </a:xfrm>
           <a:prstGeom prst="rect">
             <a:avLst/>
@@ -8007,27 +7777,27 @@
               <a:buNone/>
             </a:pPr>
             <a:r>
-              <a:rPr lang="en-US" sz="1300" b="1" dirty="0">
+              <a:rPr lang="en-US" sz="1000" b="1" dirty="0">
                 <a:solidFill>
                   <a:srgbClr val="FFFFFF"/>
                 </a:solidFill>
               </a:rPr>
               <a:t>2</a:t>
             </a:r>
-            <a:endParaRPr lang="en-US" sz="1300" dirty="0"/>
-          </a:p>
-        </p:txBody>
-      </p:sp>
-      <p:sp>
-        <p:nvSpPr>
-          <p:cNvPr id="12" name="Text 10"/>
-          <p:cNvSpPr/>
-          <p:nvPr/>
-        </p:nvSpPr>
-        <p:spPr>
-          <a:xfrm>
-            <a:off x="1499616" y="3154680"/>
-            <a:ext cx="1417320" cy="201168"/>
+            <a:endParaRPr lang="en-US" sz="1000" dirty="0"/>
+          </a:p>
+        </p:txBody>
+      </p:sp>
+      <p:sp>
+        <p:nvSpPr>
+          <p:cNvPr id="14" name="Text 12"/>
+          <p:cNvSpPr/>
+          <p:nvPr/>
+        </p:nvSpPr>
+        <p:spPr>
+          <a:xfrm>
+            <a:off x="5084064" y="2414016"/>
+            <a:ext cx="2267712" cy="228600"/>
           </a:xfrm>
           <a:prstGeom prst="rect">
             <a:avLst/>
@@ -8045,27 +7815,27 @@
               <a:buNone/>
             </a:pPr>
             <a:r>
-              <a:rPr lang="en-US" sz="1200" b="1" dirty="0">
-                <a:solidFill>
-                  <a:srgbClr val="18302C"/>
+              <a:rPr lang="en-US" sz="1300" b="1" dirty="0">
+                <a:solidFill>
+                  <a:srgbClr val="FFFFFF"/>
                 </a:solidFill>
               </a:rPr>
               <a:t>Роли и мандат</a:t>
             </a:r>
-            <a:endParaRPr lang="en-US" sz="1200" dirty="0"/>
-          </a:p>
-        </p:txBody>
-      </p:sp>
-      <p:sp>
-        <p:nvSpPr>
-          <p:cNvPr id="13" name="Text 11"/>
-          <p:cNvSpPr/>
-          <p:nvPr/>
-        </p:nvSpPr>
-        <p:spPr>
-          <a:xfrm>
-            <a:off x="1499616" y="3401568"/>
-            <a:ext cx="1463040" cy="320040"/>
+            <a:endParaRPr lang="en-US" sz="1300" dirty="0"/>
+          </a:p>
+        </p:txBody>
+      </p:sp>
+      <p:sp>
+        <p:nvSpPr>
+          <p:cNvPr id="15" name="Text 13"/>
+          <p:cNvSpPr/>
+          <p:nvPr/>
+        </p:nvSpPr>
+        <p:spPr>
+          <a:xfrm>
+            <a:off x="4498848" y="2944368"/>
+            <a:ext cx="2788920" cy="338328"/>
           </a:xfrm>
           <a:prstGeom prst="rect">
             <a:avLst/>
@@ -8083,27 +7853,54 @@
               <a:buNone/>
             </a:pPr>
             <a:r>
-              <a:rPr lang="en-US" sz="940" dirty="0">
-                <a:solidFill>
-                  <a:srgbClr val="60746F"/>
-                </a:solidFill>
-              </a:rPr>
-              <a:t>Бизнес-заказчик, спонсор, руководитель проекта, порядок AI-комитета</a:t>
-            </a:r>
-            <a:endParaRPr lang="en-US" sz="940" dirty="0"/>
-          </a:p>
-        </p:txBody>
-      </p:sp>
-      <p:sp>
-        <p:nvSpPr>
-          <p:cNvPr id="14" name="Shape 12"/>
-          <p:cNvSpPr/>
-          <p:nvPr/>
-        </p:nvSpPr>
-        <p:spPr>
-          <a:xfrm>
-            <a:off x="822960" y="3922776"/>
-            <a:ext cx="530352" cy="530352"/>
+              <a:rPr lang="en-US" sz="1120" dirty="0">
+                <a:solidFill>
+                  <a:srgbClr val="D9E7E2"/>
+                </a:solidFill>
+              </a:rPr>
+              <a:t>Бизнес-заказчик, спонсор, руководитель проекта, AI-комитет</a:t>
+            </a:r>
+            <a:endParaRPr lang="en-US" sz="1120" dirty="0"/>
+          </a:p>
+        </p:txBody>
+      </p:sp>
+      <p:sp>
+        <p:nvSpPr>
+          <p:cNvPr id="16" name="Shape 14"/>
+          <p:cNvSpPr/>
+          <p:nvPr/>
+        </p:nvSpPr>
+        <p:spPr>
+          <a:xfrm>
+            <a:off x="713232" y="3950208"/>
+            <a:ext cx="3255264" cy="1335024"/>
+          </a:xfrm>
+          <a:prstGeom prst="roundRect">
+            <a:avLst>
+              <a:gd name="adj" fmla="val 4795"/>
+            </a:avLst>
+          </a:prstGeom>
+          <a:solidFill>
+            <a:srgbClr val="1E554D"/>
+          </a:solidFill>
+          <a:ln w="10160">
+            <a:solidFill>
+              <a:srgbClr val="3C786D"/>
+            </a:solidFill>
+            <a:prstDash val="solid"/>
+          </a:ln>
+        </p:spPr>
+      </p:sp>
+      <p:sp>
+        <p:nvSpPr>
+          <p:cNvPr id="17" name="Shape 15"/>
+          <p:cNvSpPr/>
+          <p:nvPr/>
+        </p:nvSpPr>
+        <p:spPr>
+          <a:xfrm>
+            <a:off x="896112" y="4151376"/>
+            <a:ext cx="438912" cy="438912"/>
           </a:xfrm>
           <a:prstGeom prst="ellipse">
             <a:avLst/>
@@ -8121,14 +7918,14 @@
       </p:sp>
       <p:sp>
         <p:nvSpPr>
-          <p:cNvPr id="15" name="Text 13"/>
-          <p:cNvSpPr/>
-          <p:nvPr/>
-        </p:nvSpPr>
-        <p:spPr>
-          <a:xfrm>
-            <a:off x="822960" y="4050792"/>
-            <a:ext cx="530352" cy="164592"/>
+          <p:cNvPr id="18" name="Text 16"/>
+          <p:cNvSpPr/>
+          <p:nvPr/>
+        </p:nvSpPr>
+        <p:spPr>
+          <a:xfrm>
+            <a:off x="896112" y="4270248"/>
+            <a:ext cx="438912" cy="128016"/>
           </a:xfrm>
           <a:prstGeom prst="rect">
             <a:avLst/>
@@ -8144,27 +7941,27 @@
               <a:buNone/>
             </a:pPr>
             <a:r>
-              <a:rPr lang="en-US" sz="1300" b="1" dirty="0">
+              <a:rPr lang="en-US" sz="1000" b="1" dirty="0">
                 <a:solidFill>
                   <a:srgbClr val="FFFFFF"/>
                 </a:solidFill>
               </a:rPr>
               <a:t>3</a:t>
             </a:r>
-            <a:endParaRPr lang="en-US" sz="1300" dirty="0"/>
-          </a:p>
-        </p:txBody>
-      </p:sp>
-      <p:sp>
-        <p:nvSpPr>
-          <p:cNvPr id="16" name="Text 14"/>
-          <p:cNvSpPr/>
-          <p:nvPr/>
-        </p:nvSpPr>
-        <p:spPr>
-          <a:xfrm>
-            <a:off x="1499616" y="3950208"/>
-            <a:ext cx="1417320" cy="201168"/>
+            <a:endParaRPr lang="en-US" sz="1000" dirty="0"/>
+          </a:p>
+        </p:txBody>
+      </p:sp>
+      <p:sp>
+        <p:nvSpPr>
+          <p:cNvPr id="19" name="Text 17"/>
+          <p:cNvSpPr/>
+          <p:nvPr/>
+        </p:nvSpPr>
+        <p:spPr>
+          <a:xfrm>
+            <a:off x="1481328" y="4151376"/>
+            <a:ext cx="2267712" cy="228600"/>
           </a:xfrm>
           <a:prstGeom prst="rect">
             <a:avLst/>
@@ -8182,27 +7979,27 @@
               <a:buNone/>
             </a:pPr>
             <a:r>
-              <a:rPr lang="en-US" sz="1200" b="1" dirty="0">
-                <a:solidFill>
-                  <a:srgbClr val="18302C"/>
+              <a:rPr lang="en-US" sz="1300" b="1" dirty="0">
+                <a:solidFill>
+                  <a:srgbClr val="FFFFFF"/>
                 </a:solidFill>
               </a:rPr>
               <a:t>Принцип безопасности</a:t>
             </a:r>
-            <a:endParaRPr lang="en-US" sz="1200" dirty="0"/>
-          </a:p>
-        </p:txBody>
-      </p:sp>
-      <p:sp>
-        <p:nvSpPr>
-          <p:cNvPr id="17" name="Text 15"/>
-          <p:cNvSpPr/>
-          <p:nvPr/>
-        </p:nvSpPr>
-        <p:spPr>
-          <a:xfrm>
-            <a:off x="1499616" y="4197096"/>
-            <a:ext cx="1463040" cy="320040"/>
+            <a:endParaRPr lang="en-US" sz="1300" dirty="0"/>
+          </a:p>
+        </p:txBody>
+      </p:sp>
+      <p:sp>
+        <p:nvSpPr>
+          <p:cNvPr id="20" name="Text 18"/>
+          <p:cNvSpPr/>
+          <p:nvPr/>
+        </p:nvSpPr>
+        <p:spPr>
+          <a:xfrm>
+            <a:off x="896112" y="4681728"/>
+            <a:ext cx="2788920" cy="338328"/>
           </a:xfrm>
           <a:prstGeom prst="rect">
             <a:avLst/>
@@ -8220,27 +8017,54 @@
               <a:buNone/>
             </a:pPr>
             <a:r>
-              <a:rPr lang="en-US" sz="940" dirty="0">
-                <a:solidFill>
-                  <a:srgbClr val="60746F"/>
+              <a:rPr lang="en-US" sz="1120" dirty="0">
+                <a:solidFill>
+                  <a:srgbClr val="D9E7E2"/>
                 </a:solidFill>
               </a:rPr>
               <a:t>Контролируемый контур для ПДн, КТ и конфиденциальных данных</a:t>
             </a:r>
-            <a:endParaRPr lang="en-US" sz="940" dirty="0"/>
-          </a:p>
-        </p:txBody>
-      </p:sp>
-      <p:sp>
-        <p:nvSpPr>
-          <p:cNvPr id="18" name="Shape 16"/>
-          <p:cNvSpPr/>
-          <p:nvPr/>
-        </p:nvSpPr>
-        <p:spPr>
-          <a:xfrm>
-            <a:off x="822960" y="4718304"/>
-            <a:ext cx="530352" cy="530352"/>
+            <a:endParaRPr lang="en-US" sz="1120" dirty="0"/>
+          </a:p>
+        </p:txBody>
+      </p:sp>
+      <p:sp>
+        <p:nvSpPr>
+          <p:cNvPr id="21" name="Shape 19"/>
+          <p:cNvSpPr/>
+          <p:nvPr/>
+        </p:nvSpPr>
+        <p:spPr>
+          <a:xfrm>
+            <a:off x="4315968" y="3950208"/>
+            <a:ext cx="3255264" cy="1335024"/>
+          </a:xfrm>
+          <a:prstGeom prst="roundRect">
+            <a:avLst>
+              <a:gd name="adj" fmla="val 4795"/>
+            </a:avLst>
+          </a:prstGeom>
+          <a:solidFill>
+            <a:srgbClr val="1E554D"/>
+          </a:solidFill>
+          <a:ln w="10160">
+            <a:solidFill>
+              <a:srgbClr val="3C786D"/>
+            </a:solidFill>
+            <a:prstDash val="solid"/>
+          </a:ln>
+        </p:spPr>
+      </p:sp>
+      <p:sp>
+        <p:nvSpPr>
+          <p:cNvPr id="22" name="Shape 20"/>
+          <p:cNvSpPr/>
+          <p:nvPr/>
+        </p:nvSpPr>
+        <p:spPr>
+          <a:xfrm>
+            <a:off x="4498848" y="4151376"/>
+            <a:ext cx="438912" cy="438912"/>
           </a:xfrm>
           <a:prstGeom prst="ellipse">
             <a:avLst/>
@@ -8258,14 +8082,14 @@
       </p:sp>
       <p:sp>
         <p:nvSpPr>
-          <p:cNvPr id="19" name="Text 17"/>
-          <p:cNvSpPr/>
-          <p:nvPr/>
-        </p:nvSpPr>
-        <p:spPr>
-          <a:xfrm>
-            <a:off x="822960" y="4846320"/>
-            <a:ext cx="530352" cy="164592"/>
+          <p:cNvPr id="23" name="Text 21"/>
+          <p:cNvSpPr/>
+          <p:nvPr/>
+        </p:nvSpPr>
+        <p:spPr>
+          <a:xfrm>
+            <a:off x="4498848" y="4270248"/>
+            <a:ext cx="438912" cy="128016"/>
           </a:xfrm>
           <a:prstGeom prst="rect">
             <a:avLst/>
@@ -8281,27 +8105,27 @@
               <a:buNone/>
             </a:pPr>
             <a:r>
-              <a:rPr lang="en-US" sz="1300" b="1" dirty="0">
+              <a:rPr lang="en-US" sz="1000" b="1" dirty="0">
                 <a:solidFill>
                   <a:srgbClr val="FFFFFF"/>
                 </a:solidFill>
               </a:rPr>
               <a:t>4</a:t>
             </a:r>
-            <a:endParaRPr lang="en-US" sz="1300" dirty="0"/>
-          </a:p>
-        </p:txBody>
-      </p:sp>
-      <p:sp>
-        <p:nvSpPr>
-          <p:cNvPr id="20" name="Text 18"/>
-          <p:cNvSpPr/>
-          <p:nvPr/>
-        </p:nvSpPr>
-        <p:spPr>
-          <a:xfrm>
-            <a:off x="1499616" y="4745736"/>
-            <a:ext cx="1417320" cy="201168"/>
+            <a:endParaRPr lang="en-US" sz="1000" dirty="0"/>
+          </a:p>
+        </p:txBody>
+      </p:sp>
+      <p:sp>
+        <p:nvSpPr>
+          <p:cNvPr id="24" name="Text 22"/>
+          <p:cNvSpPr/>
+          <p:nvPr/>
+        </p:nvSpPr>
+        <p:spPr>
+          <a:xfrm>
+            <a:off x="5084064" y="4151376"/>
+            <a:ext cx="2267712" cy="228600"/>
           </a:xfrm>
           <a:prstGeom prst="rect">
             <a:avLst/>
@@ -8319,27 +8143,27 @@
               <a:buNone/>
             </a:pPr>
             <a:r>
-              <a:rPr lang="en-US" sz="1200" b="1" dirty="0">
-                <a:solidFill>
-                  <a:srgbClr val="18302C"/>
+              <a:rPr lang="en-US" sz="1300" b="1" dirty="0">
+                <a:solidFill>
+                  <a:srgbClr val="FFFFFF"/>
                 </a:solidFill>
               </a:rPr>
               <a:t>Портфель пилотов</a:t>
             </a:r>
-            <a:endParaRPr lang="en-US" sz="1200" dirty="0"/>
-          </a:p>
-        </p:txBody>
-      </p:sp>
-      <p:sp>
-        <p:nvSpPr>
-          <p:cNvPr id="21" name="Text 19"/>
-          <p:cNvSpPr/>
-          <p:nvPr/>
-        </p:nvSpPr>
-        <p:spPr>
-          <a:xfrm>
-            <a:off x="1499616" y="4992624"/>
-            <a:ext cx="1463040" cy="320040"/>
+            <a:endParaRPr lang="en-US" sz="1300" dirty="0"/>
+          </a:p>
+        </p:txBody>
+      </p:sp>
+      <p:sp>
+        <p:nvSpPr>
+          <p:cNvPr id="25" name="Text 23"/>
+          <p:cNvSpPr/>
+          <p:nvPr/>
+        </p:nvSpPr>
+        <p:spPr>
+          <a:xfrm>
+            <a:off x="4498848" y="4681728"/>
+            <a:ext cx="2788920" cy="338328"/>
           </a:xfrm>
           <a:prstGeom prst="rect">
             <a:avLst/>
@@ -8357,31 +8181,31 @@
               <a:buNone/>
             </a:pPr>
             <a:r>
-              <a:rPr lang="en-US" sz="940" dirty="0">
-                <a:solidFill>
-                  <a:srgbClr val="60746F"/>
-                </a:solidFill>
-              </a:rPr>
-              <a:t>Отбор 2–3 сценариев с владельцами, метриками и ИБ-допуском</a:t>
-            </a:r>
-            <a:endParaRPr lang="en-US" sz="940" dirty="0"/>
-          </a:p>
-        </p:txBody>
-      </p:sp>
-      <p:sp>
-        <p:nvSpPr>
-          <p:cNvPr id="22" name="Shape 20"/>
-          <p:cNvSpPr/>
-          <p:nvPr/>
-        </p:nvSpPr>
-        <p:spPr>
-          <a:xfrm>
-            <a:off x="8522208" y="1874520"/>
-            <a:ext cx="2633472" cy="3364992"/>
+              <a:rPr lang="en-US" sz="1120" dirty="0">
+                <a:solidFill>
+                  <a:srgbClr val="D9E7E2"/>
+                </a:solidFill>
+              </a:rPr>
+              <a:t>2–3 сценария с владельцами, метриками и ИБ-допуском</a:t>
+            </a:r>
+            <a:endParaRPr lang="en-US" sz="1120" dirty="0"/>
+          </a:p>
+        </p:txBody>
+      </p:sp>
+      <p:sp>
+        <p:nvSpPr>
+          <p:cNvPr id="26" name="Shape 24"/>
+          <p:cNvSpPr/>
+          <p:nvPr/>
+        </p:nvSpPr>
+        <p:spPr>
+          <a:xfrm>
+            <a:off x="8247888" y="2212848"/>
+            <a:ext cx="3063240" cy="3072384"/>
           </a:xfrm>
           <a:prstGeom prst="roundRect">
             <a:avLst>
-              <a:gd name="adj" fmla="val 3472"/>
+              <a:gd name="adj" fmla="val 2985"/>
             </a:avLst>
           </a:prstGeom>
           <a:solidFill>
@@ -8397,14 +8221,14 @@
       </p:sp>
       <p:sp>
         <p:nvSpPr>
-          <p:cNvPr id="23" name="Text 21"/>
-          <p:cNvSpPr/>
-          <p:nvPr/>
-        </p:nvSpPr>
-        <p:spPr>
-          <a:xfrm>
-            <a:off x="8814816" y="2267712"/>
-            <a:ext cx="2048256" cy="237744"/>
+          <p:cNvPr id="27" name="Text 25"/>
+          <p:cNvSpPr/>
+          <p:nvPr/>
+        </p:nvSpPr>
+        <p:spPr>
+          <a:xfrm>
+            <a:off x="8595360" y="2615184"/>
+            <a:ext cx="2359152" cy="237744"/>
           </a:xfrm>
           <a:prstGeom prst="rect">
             <a:avLst/>
@@ -8420,27 +8244,27 @@
               <a:buNone/>
             </a:pPr>
             <a:r>
-              <a:rPr lang="en-US" sz="1300" b="1" dirty="0">
+              <a:rPr lang="en-US" sz="1400" b="1" dirty="0">
                 <a:solidFill>
                   <a:srgbClr val="BDE3D7"/>
                 </a:solidFill>
               </a:rPr>
               <a:t>Не запрашивается</a:t>
             </a:r>
-            <a:endParaRPr lang="en-US" sz="1300" dirty="0"/>
-          </a:p>
-        </p:txBody>
-      </p:sp>
-      <p:sp>
-        <p:nvSpPr>
-          <p:cNvPr id="24" name="Text 22"/>
-          <p:cNvSpPr/>
-          <p:nvPr/>
-        </p:nvSpPr>
-        <p:spPr>
-          <a:xfrm>
-            <a:off x="8823960" y="2816352"/>
-            <a:ext cx="2029968" cy="1051560"/>
+            <a:endParaRPr lang="en-US" sz="1400" dirty="0"/>
+          </a:p>
+        </p:txBody>
+      </p:sp>
+      <p:sp>
+        <p:nvSpPr>
+          <p:cNvPr id="28" name="Text 26"/>
+          <p:cNvSpPr/>
+          <p:nvPr/>
+        </p:nvSpPr>
+        <p:spPr>
+          <a:xfrm>
+            <a:off x="8622792" y="3182112"/>
+            <a:ext cx="2304288" cy="1078992"/>
           </a:xfrm>
           <a:prstGeom prst="rect">
             <a:avLst/>
@@ -8458,62 +8282,62 @@
               <a:buNone/>
             </a:pPr>
             <a:r>
-              <a:rPr lang="en-US" sz="1800" b="1" dirty="0">
+              <a:rPr lang="en-US" sz="1900" b="1" dirty="0">
                 <a:solidFill>
                   <a:srgbClr val="FFFFFF"/>
                 </a:solidFill>
               </a:rPr>
               <a:t>массовая закупка</a:t>
             </a:r>
-            <a:endParaRPr lang="en-US" sz="1800" dirty="0"/>
+            <a:endParaRPr lang="en-US" sz="1900" dirty="0"/>
           </a:p>
           <a:p>
             <a:pPr algn="ctr" indent="0" marL="0">
               <a:buNone/>
             </a:pPr>
             <a:r>
-              <a:rPr lang="en-US" sz="1800" b="1" dirty="0">
+              <a:rPr lang="en-US" sz="1900" b="1" dirty="0">
                 <a:solidFill>
                   <a:srgbClr val="FFFFFF"/>
                 </a:solidFill>
               </a:rPr>
               <a:t>или масштабирование</a:t>
             </a:r>
-            <a:endParaRPr lang="en-US" sz="1800" dirty="0"/>
+            <a:endParaRPr lang="en-US" sz="1900" dirty="0"/>
           </a:p>
           <a:p>
             <a:pPr algn="ctr" indent="0" marL="0">
               <a:buNone/>
             </a:pPr>
             <a:r>
-              <a:rPr lang="en-US" sz="1800" b="1" dirty="0">
+              <a:rPr lang="en-US" sz="1900" b="1" dirty="0">
                 <a:solidFill>
                   <a:srgbClr val="FFFFFF"/>
                 </a:solidFill>
               </a:rPr>
               <a:t>без подтверждённого</a:t>
             </a:r>
-            <a:endParaRPr lang="en-US" sz="1800" dirty="0"/>
+            <a:endParaRPr lang="en-US" sz="1900" dirty="0"/>
           </a:p>
           <a:p>
             <a:pPr algn="ctr" indent="0" marL="0">
               <a:buNone/>
             </a:pPr>
             <a:r>
-              <a:rPr lang="en-US" sz="1800" b="1" dirty="0">
+              <a:rPr lang="en-US" sz="1900" b="1" dirty="0">
                 <a:solidFill>
                   <a:srgbClr val="FFFFFF"/>
                 </a:solidFill>
               </a:rPr>
               <a:t>эффекта</a:t>
             </a:r>
-            <a:endParaRPr lang="en-US" sz="1800" dirty="0"/>
-          </a:p>
-        </p:txBody>
-      </p:sp>
-      <p:sp>
-        <p:nvSpPr>
-          <p:cNvPr id="25" name="Text 23"/>
+            <a:endParaRPr lang="en-US" sz="1900" dirty="0"/>
+          </a:p>
+        </p:txBody>
+      </p:sp>
+      <p:sp>
+        <p:nvSpPr>
+          <p:cNvPr id="29" name="Text 27"/>
           <p:cNvSpPr/>
           <p:nvPr/>
         </p:nvSpPr>

</xml_diff>

<commit_message>
docs: passport v0.2 - cost framework
</commit_message>
<xml_diff>
--- a/AI Project Passport - Energy Company/Защита паспорта проекта — НЭК ТЕХ.pptx
+++ b/AI Project Passport - Energy Company/Защита паспорта проекта — НЭК ТЕХ.pptx
@@ -4836,7 +4836,7 @@
                   <a:srgbClr val="18302C"/>
                 </a:solidFill>
               </a:rPr>
-              <a:t>Пилот 1 · публичный мониторинг PR/GR</a:t>
+              <a:t>Запуск 1 · Пилот 3: PR/GR-мониторинг</a:t>
             </a:r>
             <a:endParaRPr lang="en-US" sz="1600" dirty="0"/>
           </a:p>
@@ -4991,7 +4991,7 @@
                   <a:srgbClr val="18302C"/>
                 </a:solidFill>
               </a:rPr>
-              <a:t>Пилот 2 · AI-ассистент по базе знаний</a:t>
+              <a:t>Запуск 2 · Пилот 1: AI-ассистент</a:t>
             </a:r>
             <a:endParaRPr lang="en-US" sz="1600" dirty="0"/>
           </a:p>
@@ -5146,7 +5146,7 @@
                   <a:srgbClr val="18302C"/>
                 </a:solidFill>
               </a:rPr>
-              <a:t>Пилот 3 · Service Desk</a:t>
+              <a:t>Запуск 3 · Пилот 2: Service Desk</a:t>
             </a:r>
             <a:endParaRPr lang="en-US" sz="1600" dirty="0"/>
           </a:p>
@@ -5240,7 +5240,7 @@
                   <a:srgbClr val="60746F"/>
                 </a:solidFill>
               </a:rPr>
-              <a:t>Бухгалтерская первичка — кандидат следующей волны после оценки ПДн/КТ, интеграций и качества данных.</a:t>
+              <a:t>Пилот 4 · бухгалтерская первичка — кандидат следующей волны после оценки ПДн/КТ, интеграций и качества данных.</a:t>
             </a:r>
             <a:endParaRPr lang="en-US" sz="1130" dirty="0"/>
           </a:p>
@@ -8287,7 +8287,7 @@
                   <a:srgbClr val="FFFFFF"/>
                 </a:solidFill>
               </a:rPr>
-              <a:t>массовая закупка</a:t>
+              <a:t>бюджет на этапе G0, массовая закупка</a:t>
             </a:r>
             <a:endParaRPr lang="en-US" sz="1900" dirty="0"/>
           </a:p>
@@ -8365,7 +8365,7 @@
                   <a:srgbClr val="A6C4BC"/>
                 </a:solidFill>
               </a:rPr>
-              <a:t>Следующий шаг — управляемый старт и проверка гипотез на пилотах.</a:t>
+              <a:t>Следующий шаг — управляемый старт. Смета пилотной волны (вилка 15–70 млн ₽) — отдельным решением G3 по итогам обследования.</a:t>
             </a:r>
             <a:endParaRPr lang="en-US" sz="1100" dirty="0"/>
           </a:p>

</xml_diff>

<commit_message>
docs: passport v0.3 — Phase 0 (CPU pilot), v2.0 financials, Moscow FOT rates
- new note 16: Phase 0 (OpenWebUI + Qwen3.5 on CPU), model ladder
  (4B/9B/35B-A3B MoE), focus group, Gate F0 criteria, IB constraint
- 13: two-step investment model (Phase0 -> GPU after Gate F0), real budget
  table (80.9M, FOT 43%), NPV/IRR by scenario, updated to v0.3
- 12: Phase 0 track + Gate F0 decision gate in roadmap
- 15: cost answer with two-step figures, new Phase 0 Q&A, updated messaging
- 11: two Phase 0 risks (CPU perf, sensitive data on non-attested contour)
- 10: Qwen3.5 in options, CPU-contour public-data-only constraint
- 00/README: link note 16, status update
- deck: new Phase 0 slide (pos 5), slide 8 v2.0 cost figures
- remove stray Untitled.canvas
</commit_message>
<xml_diff>
--- a/AI Project Passport - Energy Company/Защита паспорта проекта — НЭК ТЕХ.pptx
+++ b/AI Project Passport - Energy Company/Защита паспорта проекта — НЭК ТЕХ.pptx
@@ -9,6 +9,7 @@
     <p:sldId id="257" r:id="rId3"/>
     <p:sldId id="258" r:id="rId4"/>
     <p:sldId id="259" r:id="rId5"/>
+    <p:sldId id="264" r:id="rId15"/>
     <p:sldId id="260" r:id="rId6"/>
     <p:sldId id="261" r:id="rId7"/>
     <p:sldId id="262" r:id="rId8"/>
@@ -7694,7 +7695,7 @@
                   <a:srgbClr val="D9E7E2"/>
                 </a:solidFill>
               </a:rPr>
-              <a:t>Обследование и подготовка пилотов после защиты паспорта</a:t>
+              <a:t>Фаза 0 (CPU-пилот) + обследование после защиты паспорта</a:t>
             </a:r>
             <a:endParaRPr lang="en-US" sz="1120" dirty="0"/>
           </a:p>
@@ -8287,7 +8288,7 @@
                   <a:srgbClr val="FFFFFF"/>
                 </a:solidFill>
               </a:rPr>
-              <a:t>бюджет на этапе G0, массовая закупка</a:t>
+              <a:t>крупный бюджет на G0, массовая закупка</a:t>
             </a:r>
             <a:endParaRPr lang="en-US" sz="1900" dirty="0"/>
           </a:p>
@@ -8365,9 +8366,1165 @@
                   <a:srgbClr val="A6C4BC"/>
                 </a:solidFill>
               </a:rPr>
-              <a:t>Следующий шаг — управляемый старт. Смета пилотной волны (вилка 15–70 млн ₽) — отдельным решением G3 по итогам обследования.</a:t>
+              <a:t>Двухступенчато: безусловно ≈12 млн ₽ (Фаза 0 + обследование); GPU ≈22 млн ₽ — только после Gate Ф0. Бюджет Этапа 1 — 80,9 млн ₽.</a:t>
             </a:r>
             <a:endParaRPr lang="en-US" sz="1100" dirty="0"/>
+          </a:p>
+        </p:txBody>
+      </p:sp>
+    </p:spTree>
+  </p:cSld>
+  <p:clrMapOvr>
+    <a:masterClrMapping/>
+  </p:clrMapOvr>
+</p:sld>
+</file>
+
+<file path=ppt/slides/slide9.xml><?xml version="1.0" encoding="utf-8"?>
+<p:sld xmlns:a="http://schemas.openxmlformats.org/drawingml/2006/main" xmlns:r="http://schemas.openxmlformats.org/officeDocument/2006/relationships" xmlns:p="http://schemas.openxmlformats.org/presentationml/2006/main">
+  <p:cSld name="Slide 9">
+    <p:spTree>
+      <p:nvGrpSpPr>
+        <p:cNvPr id="1" name=""/>
+        <p:cNvGrpSpPr/>
+        <p:nvPr/>
+      </p:nvGrpSpPr>
+      <p:grpSpPr>
+        <a:xfrm>
+          <a:off x="0" y="0"/>
+          <a:ext cx="0" cy="0"/>
+          <a:chOff x="0" y="0"/>
+          <a:chExt cx="0" cy="0"/>
+        </a:xfrm>
+      </p:grpSpPr>
+      <p:sp>
+        <p:nvSpPr>
+          <p:cNvPr id="2" name="Text 0"/>
+          <p:cNvSpPr/>
+          <p:nvPr/>
+        </p:nvSpPr>
+        <p:spPr>
+          <a:xfrm>
+            <a:off x="475488" y="384048"/>
+            <a:ext cx="4389120" cy="219456"/>
+          </a:xfrm>
+          <a:prstGeom prst="rect">
+            <a:avLst/>
+          </a:prstGeom>
+          <a:noFill/>
+          <a:ln/>
+        </p:spPr>
+        <p:txBody>
+          <a:bodyPr wrap="square" lIns="0" tIns="0" rIns="0" bIns="0" rtlCol="0" anchor="ctr"/>
+          <a:lstStyle/>
+          <a:p>
+            <a:pPr indent="0" marL="0">
+              <a:buNone/>
+            </a:pPr>
+            <a:r>
+              <a:rPr lang="en-US" sz="1000" b="1" spc="130" kern="0" dirty="0">
+                <a:solidFill>
+                  <a:srgbClr val="2F8B7B"/>
+                </a:solidFill>
+              </a:rPr>
+              <a:t>ФАЗА 0 · ПРОВЕРКА ПЕРЕД ЗАКУПКОЙ</a:t>
+            </a:r>
+            <a:endParaRPr lang="en-US" sz="1000" dirty="0"/>
+          </a:p>
+        </p:txBody>
+      </p:sp>
+      <p:sp>
+        <p:nvSpPr>
+          <p:cNvPr id="3" name="Text 1"/>
+          <p:cNvSpPr/>
+          <p:nvPr/>
+        </p:nvSpPr>
+        <p:spPr>
+          <a:xfrm>
+            <a:off x="475488" y="685800"/>
+            <a:ext cx="10789920" cy="658368"/>
+          </a:xfrm>
+          <a:prstGeom prst="rect">
+            <a:avLst/>
+          </a:prstGeom>
+          <a:noFill/>
+          <a:ln/>
+        </p:spPr>
+        <p:txBody>
+          <a:bodyPr wrap="square" lIns="0" tIns="0" rIns="0" bIns="0" rtlCol="0" anchor="ctr">
+            <a:normAutofit/>
+          </a:bodyPr>
+          <a:lstStyle/>
+          <a:p>
+            <a:pPr indent="0" marL="0">
+              <a:buNone/>
+            </a:pPr>
+            <a:r>
+              <a:rPr lang="en-US" sz="2800" b="1" dirty="0">
+                <a:solidFill>
+                  <a:srgbClr val="18302C"/>
+                </a:solidFill>
+              </a:rPr>
+              <a:t>Сначала спрос на бесплатном стеке — потом закупка GPU</a:t>
+            </a:r>
+            <a:endParaRPr lang="en-US" sz="2800" dirty="0"/>
+          </a:p>
+        </p:txBody>
+      </p:sp>
+      <p:sp>
+        <p:nvSpPr>
+          <p:cNvPr id="4" name="Text 2"/>
+          <p:cNvSpPr/>
+          <p:nvPr/>
+        </p:nvSpPr>
+        <p:spPr>
+          <a:xfrm>
+            <a:off x="457200" y="6537960"/>
+            <a:ext cx="7040880" cy="146304"/>
+          </a:xfrm>
+          <a:prstGeom prst="rect">
+            <a:avLst/>
+          </a:prstGeom>
+          <a:noFill/>
+          <a:ln/>
+        </p:spPr>
+        <p:txBody>
+          <a:bodyPr wrap="square" lIns="0" tIns="0" rIns="0" bIns="0" rtlCol="0" anchor="ctr"/>
+          <a:lstStyle/>
+          <a:p>
+            <a:pPr indent="0" marL="0">
+              <a:buNone/>
+            </a:pPr>
+            <a:r>
+              <a:rPr lang="en-US" sz="850" dirty="0">
+                <a:solidFill>
+                  <a:srgbClr val="D9E7E2"/>
+                </a:solidFill>
+                <a:latin typeface="Aptos" pitchFamily="34" charset="0"/>
+                <a:ea typeface="Aptos" pitchFamily="34" charset="-122"/>
+                <a:cs typeface="Aptos" pitchFamily="34" charset="-120"/>
+              </a:rPr>
+              <a:t>ООО «НЭК ТЕХ» · Проект внедрения ИИ</a:t>
+            </a:r>
+            <a:endParaRPr lang="en-US" sz="850" dirty="0"/>
+          </a:p>
+        </p:txBody>
+      </p:sp>
+      <p:sp>
+        <p:nvSpPr>
+          <p:cNvPr id="5" name="Text 3"/>
+          <p:cNvSpPr/>
+          <p:nvPr/>
+        </p:nvSpPr>
+        <p:spPr>
+          <a:xfrm>
+            <a:off x="475488" y="1353312"/>
+            <a:ext cx="10881360" cy="347472"/>
+          </a:xfrm>
+          <a:prstGeom prst="rect">
+            <a:avLst/>
+          </a:prstGeom>
+          <a:noFill/>
+          <a:ln/>
+        </p:spPr>
+        <p:txBody>
+          <a:bodyPr wrap="square" lIns="0" tIns="0" rIns="0" bIns="0" rtlCol="0" anchor="ctr">
+            <a:normAutofit/>
+          </a:bodyPr>
+          <a:lstStyle/>
+          <a:p>
+            <a:pPr indent="0" marL="0">
+              <a:buNone/>
+            </a:pPr>
+            <a:r>
+              <a:rPr lang="en-US" sz="1450" dirty="0">
+                <a:solidFill>
+                  <a:srgbClr val="60746F"/>
+                </a:solidFill>
+              </a:rPr>
+              <a:t>6–10 недель на OpenWebUI + Qwen3.5 (открытые веса) на CPU, без GPU. Проверяем UX и спрос на фокус-группе, собираем сценарии.</a:t>
+            </a:r>
+            <a:endParaRPr lang="en-US" sz="1450" dirty="0"/>
+          </a:p>
+        </p:txBody>
+      </p:sp>
+      <p:sp>
+        <p:nvSpPr>
+          <p:cNvPr id="6" name="Shape 4"/>
+          <p:cNvSpPr/>
+          <p:nvPr/>
+        </p:nvSpPr>
+        <p:spPr>
+          <a:xfrm>
+            <a:off x="658368" y="2084832"/>
+            <a:ext cx="3419856" cy="1298448"/>
+          </a:xfrm>
+          <a:prstGeom prst="roundRect">
+            <a:avLst>
+              <a:gd name="adj" fmla="val 5634"/>
+            </a:avLst>
+          </a:prstGeom>
+          <a:solidFill>
+            <a:srgbClr val="FFFFFF"/>
+          </a:solidFill>
+          <a:ln w="8890">
+            <a:solidFill>
+              <a:srgbClr val="D7E1DE"/>
+            </a:solidFill>
+            <a:prstDash val="solid"/>
+          </a:ln>
+          <a:effectLst>
+            <a:outerShdw sx="100000" sy="100000" kx="0" ky="0" algn="bl" rotWithShape="0" blurRad="25400" dist="50800" dir="2700000">
+              <a:srgbClr val="6B827B">
+                <a:alpha val="10000"/>
+              </a:srgbClr>
+            </a:outerShdw>
+          </a:effectLst>
+        </p:spPr>
+      </p:sp>
+      <p:sp>
+        <p:nvSpPr>
+          <p:cNvPr id="7" name="Shape 5"/>
+          <p:cNvSpPr/>
+          <p:nvPr/>
+        </p:nvSpPr>
+        <p:spPr>
+          <a:xfrm>
+            <a:off x="658368" y="2084832"/>
+            <a:ext cx="91440" cy="1298448"/>
+          </a:xfrm>
+          <a:prstGeom prst="rect">
+            <a:avLst/>
+          </a:prstGeom>
+          <a:solidFill>
+            <a:srgbClr val="123B36"/>
+          </a:solidFill>
+          <a:ln w="12700">
+            <a:solidFill>
+              <a:srgbClr val="123B36"/>
+            </a:solidFill>
+            <a:prstDash val="solid"/>
+          </a:ln>
+        </p:spPr>
+      </p:sp>
+      <p:sp>
+        <p:nvSpPr>
+          <p:cNvPr id="8" name="Text 6"/>
+          <p:cNvSpPr/>
+          <p:nvPr/>
+        </p:nvSpPr>
+        <p:spPr>
+          <a:xfrm>
+            <a:off x="886968" y="2258568"/>
+            <a:ext cx="3035808" cy="310896"/>
+          </a:xfrm>
+          <a:prstGeom prst="rect">
+            <a:avLst/>
+          </a:prstGeom>
+          <a:noFill/>
+          <a:ln/>
+        </p:spPr>
+        <p:txBody>
+          <a:bodyPr wrap="square" lIns="0" tIns="0" rIns="0" bIns="0" rtlCol="0" anchor="ctr">
+            <a:normAutofit/>
+          </a:bodyPr>
+          <a:lstStyle/>
+          <a:p>
+            <a:pPr indent="0" marL="0">
+              <a:buNone/>
+            </a:pPr>
+            <a:r>
+              <a:rPr lang="en-US" sz="1400" b="1" dirty="0">
+                <a:solidFill>
+                  <a:srgbClr val="18302C"/>
+                </a:solidFill>
+              </a:rPr>
+              <a:t>Стек</a:t>
+            </a:r>
+            <a:endParaRPr lang="en-US" sz="1400" dirty="0"/>
+          </a:p>
+        </p:txBody>
+      </p:sp>
+      <p:sp>
+        <p:nvSpPr>
+          <p:cNvPr id="9" name="Text 7"/>
+          <p:cNvSpPr/>
+          <p:nvPr/>
+        </p:nvSpPr>
+        <p:spPr>
+          <a:xfrm>
+            <a:off x="886968" y="2688336"/>
+            <a:ext cx="3035808" cy="530352"/>
+          </a:xfrm>
+          <a:prstGeom prst="rect">
+            <a:avLst/>
+          </a:prstGeom>
+          <a:noFill/>
+          <a:ln/>
+        </p:spPr>
+        <p:txBody>
+          <a:bodyPr wrap="square" lIns="254" tIns="254" rIns="254" bIns="254" rtlCol="0" anchor="t">
+            <a:normAutofit/>
+          </a:bodyPr>
+          <a:lstStyle/>
+          <a:p>
+            <a:pPr indent="0" marL="0">
+              <a:buNone/>
+            </a:pPr>
+            <a:r>
+              <a:rPr lang="en-US" sz="1130" dirty="0">
+                <a:solidFill>
+                  <a:srgbClr val="60746F"/>
+                </a:solidFill>
+              </a:rPr>
+              <a:t>OpenWebUI + Qwen3.5</a:t>
+            </a:r>
+            <a:endParaRPr lang="en-US" sz="1130" dirty="0"/>
+          </a:p>
+          <a:p>
+            <a:pPr indent="0" marL="0">
+              <a:buNone/>
+            </a:pPr>
+            <a:r>
+              <a:rPr lang="en-US" sz="1130" dirty="0">
+                <a:solidFill>
+                  <a:srgbClr val="60746F"/>
+                </a:solidFill>
+              </a:rPr>
+              <a:t>CPU, 0 ₽ лицензий</a:t>
+            </a:r>
+            <a:endParaRPr lang="en-US" sz="1130" dirty="0"/>
+          </a:p>
+        </p:txBody>
+      </p:sp>
+      <p:sp>
+        <p:nvSpPr>
+          <p:cNvPr id="10" name="Shape 8"/>
+          <p:cNvSpPr/>
+          <p:nvPr/>
+        </p:nvSpPr>
+        <p:spPr>
+          <a:xfrm>
+            <a:off x="4370832" y="2084832"/>
+            <a:ext cx="3419856" cy="1298448"/>
+          </a:xfrm>
+          <a:prstGeom prst="roundRect">
+            <a:avLst>
+              <a:gd name="adj" fmla="val 5634"/>
+            </a:avLst>
+          </a:prstGeom>
+          <a:solidFill>
+            <a:srgbClr val="FFFFFF"/>
+          </a:solidFill>
+          <a:ln w="8890">
+            <a:solidFill>
+              <a:srgbClr val="D7E1DE"/>
+            </a:solidFill>
+            <a:prstDash val="solid"/>
+          </a:ln>
+          <a:effectLst>
+            <a:outerShdw sx="100000" sy="100000" kx="0" ky="0" algn="bl" rotWithShape="0" blurRad="25400" dist="50800" dir="2700000">
+              <a:srgbClr val="6B827B">
+                <a:alpha val="10000"/>
+              </a:srgbClr>
+            </a:outerShdw>
+          </a:effectLst>
+        </p:spPr>
+      </p:sp>
+      <p:sp>
+        <p:nvSpPr>
+          <p:cNvPr id="11" name="Shape 9"/>
+          <p:cNvSpPr/>
+          <p:nvPr/>
+        </p:nvSpPr>
+        <p:spPr>
+          <a:xfrm>
+            <a:off x="4370832" y="2084832"/>
+            <a:ext cx="91440" cy="1298448"/>
+          </a:xfrm>
+          <a:prstGeom prst="rect">
+            <a:avLst/>
+          </a:prstGeom>
+          <a:solidFill>
+            <a:srgbClr val="2F8B7B"/>
+          </a:solidFill>
+          <a:ln w="12700">
+            <a:solidFill>
+              <a:srgbClr val="2F8B7B"/>
+            </a:solidFill>
+            <a:prstDash val="solid"/>
+          </a:ln>
+        </p:spPr>
+      </p:sp>
+      <p:sp>
+        <p:nvSpPr>
+          <p:cNvPr id="12" name="Text 10"/>
+          <p:cNvSpPr/>
+          <p:nvPr/>
+        </p:nvSpPr>
+        <p:spPr>
+          <a:xfrm>
+            <a:off x="4599432" y="2258568"/>
+            <a:ext cx="3035808" cy="310896"/>
+          </a:xfrm>
+          <a:prstGeom prst="rect">
+            <a:avLst/>
+          </a:prstGeom>
+          <a:noFill/>
+          <a:ln/>
+        </p:spPr>
+        <p:txBody>
+          <a:bodyPr wrap="square" lIns="0" tIns="0" rIns="0" bIns="0" rtlCol="0" anchor="ctr">
+            <a:normAutofit/>
+          </a:bodyPr>
+          <a:lstStyle/>
+          <a:p>
+            <a:pPr indent="0" marL="0">
+              <a:buNone/>
+            </a:pPr>
+            <a:r>
+              <a:rPr lang="en-US" sz="1400" b="1" dirty="0">
+                <a:solidFill>
+                  <a:srgbClr val="18302C"/>
+                </a:solidFill>
+              </a:rPr>
+              <a:t>Модель</a:t>
+            </a:r>
+            <a:endParaRPr lang="en-US" sz="1400" dirty="0"/>
+          </a:p>
+        </p:txBody>
+      </p:sp>
+      <p:sp>
+        <p:nvSpPr>
+          <p:cNvPr id="13" name="Text 11"/>
+          <p:cNvSpPr/>
+          <p:nvPr/>
+        </p:nvSpPr>
+        <p:spPr>
+          <a:xfrm>
+            <a:off x="4599432" y="2688336"/>
+            <a:ext cx="3035808" cy="530352"/>
+          </a:xfrm>
+          <a:prstGeom prst="rect">
+            <a:avLst/>
+          </a:prstGeom>
+          <a:noFill/>
+          <a:ln/>
+        </p:spPr>
+        <p:txBody>
+          <a:bodyPr wrap="square" lIns="254" tIns="254" rIns="254" bIns="254" rtlCol="0" anchor="t">
+            <a:normAutofit/>
+          </a:bodyPr>
+          <a:lstStyle/>
+          <a:p>
+            <a:pPr indent="0" marL="0">
+              <a:buNone/>
+            </a:pPr>
+            <a:r>
+              <a:rPr lang="en-US" sz="1130" dirty="0">
+                <a:solidFill>
+                  <a:srgbClr val="60746F"/>
+                </a:solidFill>
+              </a:rPr>
+              <a:t>Qwen3.5 4B/9B</a:t>
+            </a:r>
+            <a:endParaRPr lang="en-US" sz="1130" dirty="0"/>
+          </a:p>
+          <a:p>
+            <a:pPr indent="0" marL="0">
+              <a:buNone/>
+            </a:pPr>
+            <a:r>
+              <a:rPr lang="en-US" sz="1130" dirty="0">
+                <a:solidFill>
+                  <a:srgbClr val="60746F"/>
+                </a:solidFill>
+              </a:rPr>
+              <a:t>или 35B-A3B (MoE)</a:t>
+            </a:r>
+            <a:endParaRPr lang="en-US" sz="1130" dirty="0"/>
+          </a:p>
+        </p:txBody>
+      </p:sp>
+      <p:sp>
+        <p:nvSpPr>
+          <p:cNvPr id="14" name="Shape 12"/>
+          <p:cNvSpPr/>
+          <p:nvPr/>
+        </p:nvSpPr>
+        <p:spPr>
+          <a:xfrm>
+            <a:off x="8083296" y="2084832"/>
+            <a:ext cx="3419856" cy="1298448"/>
+          </a:xfrm>
+          <a:prstGeom prst="roundRect">
+            <a:avLst>
+              <a:gd name="adj" fmla="val 5634"/>
+            </a:avLst>
+          </a:prstGeom>
+          <a:solidFill>
+            <a:srgbClr val="FFFFFF"/>
+          </a:solidFill>
+          <a:ln w="8890">
+            <a:solidFill>
+              <a:srgbClr val="D7E1DE"/>
+            </a:solidFill>
+            <a:prstDash val="solid"/>
+          </a:ln>
+          <a:effectLst>
+            <a:outerShdw sx="100000" sy="100000" kx="0" ky="0" algn="bl" rotWithShape="0" blurRad="25400" dist="50800" dir="2700000">
+              <a:srgbClr val="6B827B">
+                <a:alpha val="10000"/>
+              </a:srgbClr>
+            </a:outerShdw>
+          </a:effectLst>
+        </p:spPr>
+      </p:sp>
+      <p:sp>
+        <p:nvSpPr>
+          <p:cNvPr id="15" name="Shape 13"/>
+          <p:cNvSpPr/>
+          <p:nvPr/>
+        </p:nvSpPr>
+        <p:spPr>
+          <a:xfrm>
+            <a:off x="8083296" y="2084832"/>
+            <a:ext cx="91440" cy="1298448"/>
+          </a:xfrm>
+          <a:prstGeom prst="rect">
+            <a:avLst/>
+          </a:prstGeom>
+          <a:solidFill>
+            <a:srgbClr val="2F8B7B"/>
+          </a:solidFill>
+          <a:ln w="12700">
+            <a:solidFill>
+              <a:srgbClr val="2F8B7B"/>
+            </a:solidFill>
+            <a:prstDash val="solid"/>
+          </a:ln>
+        </p:spPr>
+      </p:sp>
+      <p:sp>
+        <p:nvSpPr>
+          <p:cNvPr id="16" name="Text 14"/>
+          <p:cNvSpPr/>
+          <p:nvPr/>
+        </p:nvSpPr>
+        <p:spPr>
+          <a:xfrm>
+            <a:off x="8311896" y="2258568"/>
+            <a:ext cx="3035808" cy="310896"/>
+          </a:xfrm>
+          <a:prstGeom prst="rect">
+            <a:avLst/>
+          </a:prstGeom>
+          <a:noFill/>
+          <a:ln/>
+        </p:spPr>
+        <p:txBody>
+          <a:bodyPr wrap="square" lIns="0" tIns="0" rIns="0" bIns="0" rtlCol="0" anchor="ctr">
+            <a:normAutofit/>
+          </a:bodyPr>
+          <a:lstStyle/>
+          <a:p>
+            <a:pPr indent="0" marL="0">
+              <a:buNone/>
+            </a:pPr>
+            <a:r>
+              <a:rPr lang="en-US" sz="1400" b="1" dirty="0">
+                <a:solidFill>
+                  <a:srgbClr val="18302C"/>
+                </a:solidFill>
+              </a:rPr>
+              <a:t>Фокус-группа</a:t>
+            </a:r>
+            <a:endParaRPr lang="en-US" sz="1400" dirty="0"/>
+          </a:p>
+        </p:txBody>
+      </p:sp>
+      <p:sp>
+        <p:nvSpPr>
+          <p:cNvPr id="17" name="Text 15"/>
+          <p:cNvSpPr/>
+          <p:nvPr/>
+        </p:nvSpPr>
+        <p:spPr>
+          <a:xfrm>
+            <a:off x="8311896" y="2688336"/>
+            <a:ext cx="3035808" cy="530352"/>
+          </a:xfrm>
+          <a:prstGeom prst="rect">
+            <a:avLst/>
+          </a:prstGeom>
+          <a:noFill/>
+          <a:ln/>
+        </p:spPr>
+        <p:txBody>
+          <a:bodyPr wrap="square" lIns="254" tIns="254" rIns="254" bIns="254" rtlCol="0" anchor="t">
+            <a:normAutofit/>
+          </a:bodyPr>
+          <a:lstStyle/>
+          <a:p>
+            <a:pPr indent="0" marL="0">
+              <a:buNone/>
+            </a:pPr>
+            <a:r>
+              <a:rPr lang="en-US" sz="1130" dirty="0">
+                <a:solidFill>
+                  <a:srgbClr val="60746F"/>
+                </a:solidFill>
+              </a:rPr>
+              <a:t>15–20 сотрудников</a:t>
+            </a:r>
+            <a:endParaRPr lang="en-US" sz="1130" dirty="0"/>
+          </a:p>
+          <a:p>
+            <a:pPr indent="0" marL="0">
+              <a:buNone/>
+            </a:pPr>
+            <a:r>
+              <a:rPr lang="en-US" sz="1130" dirty="0">
+                <a:solidFill>
+                  <a:srgbClr val="60746F"/>
+                </a:solidFill>
+              </a:rPr>
+              <a:t>CSAT, SUS, сценарии</a:t>
+            </a:r>
+            <a:endParaRPr lang="en-US" sz="1130" dirty="0"/>
+          </a:p>
+        </p:txBody>
+      </p:sp>
+      <p:sp>
+        <p:nvSpPr>
+          <p:cNvPr id="18" name="Shape 16"/>
+          <p:cNvSpPr/>
+          <p:nvPr/>
+        </p:nvSpPr>
+        <p:spPr>
+          <a:xfrm>
+            <a:off x="658368" y="3858768"/>
+            <a:ext cx="3419856" cy="1298448"/>
+          </a:xfrm>
+          <a:prstGeom prst="roundRect">
+            <a:avLst>
+              <a:gd name="adj" fmla="val 5634"/>
+            </a:avLst>
+          </a:prstGeom>
+          <a:solidFill>
+            <a:srgbClr val="FFFFFF"/>
+          </a:solidFill>
+          <a:ln w="8890">
+            <a:solidFill>
+              <a:srgbClr val="D7E1DE"/>
+            </a:solidFill>
+            <a:prstDash val="solid"/>
+          </a:ln>
+          <a:effectLst>
+            <a:outerShdw sx="100000" sy="100000" kx="0" ky="0" algn="bl" rotWithShape="0" blurRad="25400" dist="50800" dir="2700000">
+              <a:srgbClr val="6B827B">
+                <a:alpha val="10000"/>
+              </a:srgbClr>
+            </a:outerShdw>
+          </a:effectLst>
+        </p:spPr>
+      </p:sp>
+      <p:sp>
+        <p:nvSpPr>
+          <p:cNvPr id="19" name="Shape 17"/>
+          <p:cNvSpPr/>
+          <p:nvPr/>
+        </p:nvSpPr>
+        <p:spPr>
+          <a:xfrm>
+            <a:off x="658368" y="3858768"/>
+            <a:ext cx="91440" cy="1298448"/>
+          </a:xfrm>
+          <a:prstGeom prst="rect">
+            <a:avLst/>
+          </a:prstGeom>
+          <a:solidFill>
+            <a:srgbClr val="2F8B7B"/>
+          </a:solidFill>
+          <a:ln w="12700">
+            <a:solidFill>
+              <a:srgbClr val="2F8B7B"/>
+            </a:solidFill>
+            <a:prstDash val="solid"/>
+          </a:ln>
+        </p:spPr>
+      </p:sp>
+      <p:sp>
+        <p:nvSpPr>
+          <p:cNvPr id="20" name="Text 18"/>
+          <p:cNvSpPr/>
+          <p:nvPr/>
+        </p:nvSpPr>
+        <p:spPr>
+          <a:xfrm>
+            <a:off x="886968" y="4032504"/>
+            <a:ext cx="3035808" cy="310896"/>
+          </a:xfrm>
+          <a:prstGeom prst="rect">
+            <a:avLst/>
+          </a:prstGeom>
+          <a:noFill/>
+          <a:ln/>
+        </p:spPr>
+        <p:txBody>
+          <a:bodyPr wrap="square" lIns="0" tIns="0" rIns="0" bIns="0" rtlCol="0" anchor="ctr">
+            <a:normAutofit/>
+          </a:bodyPr>
+          <a:lstStyle/>
+          <a:p>
+            <a:pPr indent="0" marL="0">
+              <a:buNone/>
+            </a:pPr>
+            <a:r>
+              <a:rPr lang="en-US" sz="1400" b="1" dirty="0">
+                <a:solidFill>
+                  <a:srgbClr val="18302C"/>
+                </a:solidFill>
+              </a:rPr>
+              <a:t>Только публичные данные</a:t>
+            </a:r>
+            <a:endParaRPr lang="en-US" sz="1400" dirty="0"/>
+          </a:p>
+        </p:txBody>
+      </p:sp>
+      <p:sp>
+        <p:nvSpPr>
+          <p:cNvPr id="21" name="Text 19"/>
+          <p:cNvSpPr/>
+          <p:nvPr/>
+        </p:nvSpPr>
+        <p:spPr>
+          <a:xfrm>
+            <a:off x="886968" y="4462272"/>
+            <a:ext cx="3035808" cy="530352"/>
+          </a:xfrm>
+          <a:prstGeom prst="rect">
+            <a:avLst/>
+          </a:prstGeom>
+          <a:noFill/>
+          <a:ln/>
+        </p:spPr>
+        <p:txBody>
+          <a:bodyPr wrap="square" lIns="254" tIns="254" rIns="254" bIns="254" rtlCol="0" anchor="t">
+            <a:normAutofit/>
+          </a:bodyPr>
+          <a:lstStyle/>
+          <a:p>
+            <a:pPr indent="0" marL="0">
+              <a:buNone/>
+            </a:pPr>
+            <a:r>
+              <a:rPr lang="en-US" sz="1130" dirty="0">
+                <a:solidFill>
+                  <a:srgbClr val="60746F"/>
+                </a:solidFill>
+              </a:rPr>
+              <a:t>CPU-контур не под ПДн/КТ</a:t>
+            </a:r>
+            <a:endParaRPr lang="en-US" sz="1130" dirty="0"/>
+          </a:p>
+          <a:p>
+            <a:pPr indent="0" marL="0">
+              <a:buNone/>
+            </a:pPr>
+            <a:r>
+              <a:rPr lang="en-US" sz="1130" dirty="0">
+                <a:solidFill>
+                  <a:srgbClr val="60746F"/>
+                </a:solidFill>
+              </a:rPr>
+              <a:t>контроль ИБ</a:t>
+            </a:r>
+            <a:endParaRPr lang="en-US" sz="1130" dirty="0"/>
+          </a:p>
+        </p:txBody>
+      </p:sp>
+      <p:sp>
+        <p:nvSpPr>
+          <p:cNvPr id="22" name="Shape 20"/>
+          <p:cNvSpPr/>
+          <p:nvPr/>
+        </p:nvSpPr>
+        <p:spPr>
+          <a:xfrm>
+            <a:off x="4370832" y="3858768"/>
+            <a:ext cx="3419856" cy="1298448"/>
+          </a:xfrm>
+          <a:prstGeom prst="roundRect">
+            <a:avLst>
+              <a:gd name="adj" fmla="val 5634"/>
+            </a:avLst>
+          </a:prstGeom>
+          <a:solidFill>
+            <a:srgbClr val="FFFFFF"/>
+          </a:solidFill>
+          <a:ln w="8890">
+            <a:solidFill>
+              <a:srgbClr val="D7E1DE"/>
+            </a:solidFill>
+            <a:prstDash val="solid"/>
+          </a:ln>
+          <a:effectLst>
+            <a:outerShdw sx="100000" sy="100000" kx="0" ky="0" algn="bl" rotWithShape="0" blurRad="25400" dist="50800" dir="2700000">
+              <a:srgbClr val="6B827B">
+                <a:alpha val="10000"/>
+              </a:srgbClr>
+            </a:outerShdw>
+          </a:effectLst>
+        </p:spPr>
+      </p:sp>
+      <p:sp>
+        <p:nvSpPr>
+          <p:cNvPr id="23" name="Shape 21"/>
+          <p:cNvSpPr/>
+          <p:nvPr/>
+        </p:nvSpPr>
+        <p:spPr>
+          <a:xfrm>
+            <a:off x="4370832" y="3858768"/>
+            <a:ext cx="91440" cy="1298448"/>
+          </a:xfrm>
+          <a:prstGeom prst="rect">
+            <a:avLst/>
+          </a:prstGeom>
+          <a:solidFill>
+            <a:srgbClr val="2F8B7B"/>
+          </a:solidFill>
+          <a:ln w="12700">
+            <a:solidFill>
+              <a:srgbClr val="2F8B7B"/>
+            </a:solidFill>
+            <a:prstDash val="solid"/>
+          </a:ln>
+        </p:spPr>
+      </p:sp>
+      <p:sp>
+        <p:nvSpPr>
+          <p:cNvPr id="24" name="Text 22"/>
+          <p:cNvSpPr/>
+          <p:nvPr/>
+        </p:nvSpPr>
+        <p:spPr>
+          <a:xfrm>
+            <a:off x="4599432" y="4032504"/>
+            <a:ext cx="3035808" cy="310896"/>
+          </a:xfrm>
+          <a:prstGeom prst="rect">
+            <a:avLst/>
+          </a:prstGeom>
+          <a:noFill/>
+          <a:ln/>
+        </p:spPr>
+        <p:txBody>
+          <a:bodyPr wrap="square" lIns="0" tIns="0" rIns="0" bIns="0" rtlCol="0" anchor="ctr">
+            <a:normAutofit/>
+          </a:bodyPr>
+          <a:lstStyle/>
+          <a:p>
+            <a:pPr indent="0" marL="0">
+              <a:buNone/>
+            </a:pPr>
+            <a:r>
+              <a:rPr lang="en-US" sz="1400" b="1" dirty="0">
+                <a:solidFill>
+                  <a:srgbClr val="18302C"/>
+                </a:solidFill>
+              </a:rPr>
+              <a:t>Gate Ф0</a:t>
+            </a:r>
+            <a:endParaRPr lang="en-US" sz="1400" dirty="0"/>
+          </a:p>
+        </p:txBody>
+      </p:sp>
+      <p:sp>
+        <p:nvSpPr>
+          <p:cNvPr id="25" name="Text 23"/>
+          <p:cNvSpPr/>
+          <p:nvPr/>
+        </p:nvSpPr>
+        <p:spPr>
+          <a:xfrm>
+            <a:off x="4599432" y="4462272"/>
+            <a:ext cx="3035808" cy="530352"/>
+          </a:xfrm>
+          <a:prstGeom prst="rect">
+            <a:avLst/>
+          </a:prstGeom>
+          <a:noFill/>
+          <a:ln/>
+        </p:spPr>
+        <p:txBody>
+          <a:bodyPr wrap="square" lIns="254" tIns="254" rIns="254" bIns="254" rtlCol="0" anchor="t">
+            <a:normAutofit/>
+          </a:bodyPr>
+          <a:lstStyle/>
+          <a:p>
+            <a:pPr indent="0" marL="0">
+              <a:buNone/>
+            </a:pPr>
+            <a:r>
+              <a:rPr lang="en-US" sz="1130" dirty="0">
+                <a:solidFill>
+                  <a:srgbClr val="60746F"/>
+                </a:solidFill>
+              </a:rPr>
+              <a:t>CSAT≥70%, ≥3 подр.</a:t>
+            </a:r>
+            <a:endParaRPr lang="en-US" sz="1130" dirty="0"/>
+          </a:p>
+          <a:p>
+            <a:pPr indent="0" marL="0">
+              <a:buNone/>
+            </a:pPr>
+            <a:r>
+              <a:rPr lang="en-US" sz="1130" dirty="0">
+                <a:solidFill>
+                  <a:srgbClr val="60746F"/>
+                </a:solidFill>
+              </a:rPr>
+              <a:t>решение о GPU</a:t>
+            </a:r>
+            <a:endParaRPr lang="en-US" sz="1130" dirty="0"/>
+          </a:p>
+        </p:txBody>
+      </p:sp>
+      <p:sp>
+        <p:nvSpPr>
+          <p:cNvPr id="26" name="Shape 24"/>
+          <p:cNvSpPr/>
+          <p:nvPr/>
+        </p:nvSpPr>
+        <p:spPr>
+          <a:xfrm>
+            <a:off x="8083296" y="3858768"/>
+            <a:ext cx="3419856" cy="1298448"/>
+          </a:xfrm>
+          <a:prstGeom prst="roundRect">
+            <a:avLst>
+              <a:gd name="adj" fmla="val 5634"/>
+            </a:avLst>
+          </a:prstGeom>
+          <a:solidFill>
+            <a:srgbClr val="FFFFFF"/>
+          </a:solidFill>
+          <a:ln w="8890">
+            <a:solidFill>
+              <a:srgbClr val="D7E1DE"/>
+            </a:solidFill>
+            <a:prstDash val="solid"/>
+          </a:ln>
+          <a:effectLst>
+            <a:outerShdw sx="100000" sy="100000" kx="0" ky="0" algn="bl" rotWithShape="0" blurRad="25400" dist="50800" dir="2700000">
+              <a:srgbClr val="6B827B">
+                <a:alpha val="10000"/>
+              </a:srgbClr>
+            </a:outerShdw>
+          </a:effectLst>
+        </p:spPr>
+      </p:sp>
+      <p:sp>
+        <p:nvSpPr>
+          <p:cNvPr id="27" name="Shape 25"/>
+          <p:cNvSpPr/>
+          <p:nvPr/>
+        </p:nvSpPr>
+        <p:spPr>
+          <a:xfrm>
+            <a:off x="8083296" y="3858768"/>
+            <a:ext cx="91440" cy="1298448"/>
+          </a:xfrm>
+          <a:prstGeom prst="rect">
+            <a:avLst/>
+          </a:prstGeom>
+          <a:solidFill>
+            <a:srgbClr val="D46A58"/>
+          </a:solidFill>
+          <a:ln w="12700">
+            <a:solidFill>
+              <a:srgbClr val="D46A58"/>
+            </a:solidFill>
+            <a:prstDash val="solid"/>
+          </a:ln>
+        </p:spPr>
+      </p:sp>
+      <p:sp>
+        <p:nvSpPr>
+          <p:cNvPr id="28" name="Text 26"/>
+          <p:cNvSpPr/>
+          <p:nvPr/>
+        </p:nvSpPr>
+        <p:spPr>
+          <a:xfrm>
+            <a:off x="8311896" y="4032504"/>
+            <a:ext cx="3035808" cy="310896"/>
+          </a:xfrm>
+          <a:prstGeom prst="rect">
+            <a:avLst/>
+          </a:prstGeom>
+          <a:noFill/>
+          <a:ln/>
+        </p:spPr>
+        <p:txBody>
+          <a:bodyPr wrap="square" lIns="0" tIns="0" rIns="0" bIns="0" rtlCol="0" anchor="ctr">
+            <a:normAutofit/>
+          </a:bodyPr>
+          <a:lstStyle/>
+          <a:p>
+            <a:pPr indent="0" marL="0">
+              <a:buNone/>
+            </a:pPr>
+            <a:r>
+              <a:rPr lang="en-US" sz="1400" b="1" dirty="0">
+                <a:solidFill>
+                  <a:srgbClr val="18302C"/>
+                </a:solidFill>
+              </a:rPr>
+              <a:t>Если «нет»</a:t>
+            </a:r>
+            <a:endParaRPr lang="en-US" sz="1400" dirty="0"/>
+          </a:p>
+        </p:txBody>
+      </p:sp>
+      <p:sp>
+        <p:nvSpPr>
+          <p:cNvPr id="29" name="Text 27"/>
+          <p:cNvSpPr/>
+          <p:nvPr/>
+        </p:nvSpPr>
+        <p:spPr>
+          <a:xfrm>
+            <a:off x="8311896" y="4462272"/>
+            <a:ext cx="3035808" cy="530352"/>
+          </a:xfrm>
+          <a:prstGeom prst="rect">
+            <a:avLst/>
+          </a:prstGeom>
+          <a:noFill/>
+          <a:ln/>
+        </p:spPr>
+        <p:txBody>
+          <a:bodyPr wrap="square" lIns="254" tIns="254" rIns="254" bIns="254" rtlCol="0" anchor="t">
+            <a:normAutofit/>
+          </a:bodyPr>
+          <a:lstStyle/>
+          <a:p>
+            <a:pPr indent="0" marL="0">
+              <a:buNone/>
+            </a:pPr>
+            <a:r>
+              <a:rPr lang="en-US" sz="1130" dirty="0">
+                <a:solidFill>
+                  <a:srgbClr val="60746F"/>
+                </a:solidFill>
+              </a:rPr>
+              <a:t>GPU не закупаем</a:t>
+            </a:r>
+            <a:endParaRPr lang="en-US" sz="1130" dirty="0"/>
+          </a:p>
+          <a:p>
+            <a:pPr indent="0" marL="0">
+              <a:buNone/>
+            </a:pPr>
+            <a:r>
+              <a:rPr lang="en-US" sz="1130" dirty="0">
+                <a:solidFill>
+                  <a:srgbClr val="60746F"/>
+                </a:solidFill>
+              </a:rPr>
+              <a:t>экономия ≈22 млн ₽</a:t>
+            </a:r>
+            <a:endParaRPr lang="en-US" sz="1130" dirty="0"/>
+          </a:p>
+        </p:txBody>
+      </p:sp>
+      <p:sp>
+        <p:nvSpPr>
+          <p:cNvPr id="30" name="Text 28"/>
+          <p:cNvSpPr/>
+          <p:nvPr/>
+        </p:nvSpPr>
+        <p:spPr>
+          <a:xfrm>
+            <a:off x="777240" y="5650992"/>
+            <a:ext cx="10607040" cy="201168"/>
+          </a:xfrm>
+          <a:prstGeom prst="rect">
+            <a:avLst/>
+          </a:prstGeom>
+          <a:noFill/>
+          <a:ln/>
+        </p:spPr>
+        <p:txBody>
+          <a:bodyPr wrap="square" lIns="0" tIns="0" rIns="0" bIns="0" rtlCol="0" anchor="ctr">
+            <a:normAutofit/>
+          </a:bodyPr>
+          <a:lstStyle/>
+          <a:p>
+            <a:pPr algn="ctr" indent="0" marL="0">
+              <a:buNone/>
+            </a:pPr>
+            <a:r>
+              <a:rPr lang="en-US" sz="1150" b="1" dirty="0">
+                <a:solidFill>
+                  <a:srgbClr val="123B36"/>
+                </a:solidFill>
+              </a:rPr>
+              <a:t>Дорогую GPU-инфраструктуру (≈22 млн ₽) закупаем только после подтверждения спроса. Потери при отрицательном исходе ограничены Фазой 0 (≈1,4 млн ₽).</a:t>
+            </a:r>
+            <a:endParaRPr lang="en-US" sz="1150" dirty="0"/>
+          </a:p>
+        </p:txBody>
+      </p:sp>
+      <p:sp>
+        <p:nvSpPr>
+          <p:cNvPr id="25" name="Slide Number Placeholder 0"/>
+          <p:cNvSpPr>
+            <a:spLocks noGrp="1"/>
+          </p:cNvSpPr>
+          <p:nvPr>
+            <p:ph type="sldNum" sz="quarter" idx="4294967295"/>
+          </p:nvPr>
+        </p:nvSpPr>
+        <p:spPr>
+          <a:xfrm>
+            <a:off x="11430000" y="6519672"/>
+            <a:ext cx="800000" cy="300000"/>
+          </a:xfrm>
+          <a:prstGeom prst="rect">
+            <a:avLst/>
+          </a:prstGeom>
+          <a:extLst>
+            <a:ext uri="{C572A759-6A51-4108-AA02-DFA0A04FC94B}">
+              <ma14:wrappingTextBoxFlag xmlns:ma14="http://schemas.microsoft.com/office/mac/drawingml/2011/main" val="0"/>
+            </a:ext>
+          </a:extLst>
+        </p:spPr>
+        <p:txBody>
+          <a:bodyPr/>
+          <a:lstStyle>
+            <a:lvl1pPr>
+              <a:defRPr sz="900">
+                <a:solidFill>
+                  <a:srgbClr val="D9E7E2"/>
+                </a:solidFill>
+                <a:latin typeface="Aptos"/>
+                <a:ea typeface="Aptos"/>
+                <a:cs typeface="Aptos"/>
+              </a:defRPr>
+            </a:lvl1pPr>
+          </a:lstStyle>
+          <a:p>
+            <a:pPr algn="l"/>
+            <a:fld id="{F7021451-1387-4CA6-816F-3879F97B5CBC}" type="slidenum">
+              <a:rPr b="0" lang="en-US"/>
+              <a:t>4а</a:t>
+            </a:fld>
+            <a:endParaRPr lang="en-US"/>
           </a:p>
         </p:txBody>
       </p:sp>

</xml_diff>